<commit_message>
Update the experiment report and 26-slide visual presentation
</commit_message>
<xml_diff>
--- a/submission/ShopLens_Qwen_presentation.pptx
+++ b/submission/ShopLens_Qwen_presentation.pptx
@@ -582,7 +582,7 @@
           </a:p>
           <a:p xmlns:a="http://schemas.openxmlformats.org/drawingml/2006/main">
             <a:r>
-              <a:t>This screenshot shows a later state than the earlier zero-image, unrestricted comparison. Actual selected reference is Capri Stroller - Red Tech and text weight is 0.65. The image source is Use catalog example, not an uploaded file. Current UI limits uploads to single JPG/PNG/WebP, 8 MB and 16 megapixels. Budget filtering excludes unknown prices. Source metadata categories are not verified product types. An avoid penalty does not guarantee perfect semantic exclusion.</a:t>
+              <a:t>This screenshot shows a separate, later refined Baby state from the Model arena capture. Actual selected reference is Capri Stroller - Red Tech and text weight is 0.65. The image source is Use catalog example, not an uploaded file. Current UI limits uploads to single JPG/PNG/WebP, 8 MB and 16 megapixels. Budget filtering excludes unknown prices. Source metadata categories are not verified product types. An avoid penalty does not guarantee perfect semantic exclusion.</a:t>
             </a:r>
           </a:p>
           <a:p xmlns:a="http://schemas.openxmlformats.org/drawingml/2006/main">
@@ -2152,7 +2152,7 @@
           <a:lstStyle xmlns:a="http://schemas.openxmlformats.org/drawingml/2006/main"/>
           <a:p xmlns:a="http://schemas.openxmlformats.org/drawingml/2006/main">
             <a:r>
-              <a:t>Optional discussion: the heatmap gives a numerical alternative to the preference network. Rows are actual active history products and columns are current candidates. Entries use the complete one-hundred-and-twenty-eight-dimensional cross-tower cosine, with negative values retained. These values do not decompose the final user-network score.</a:t>
+              <a:t>Optional discussion: the original three-column product view gives photographic evidence for each model’s first visible recommendation. The catalogue contains 7,037 Baby products. Top-twelve and Top-three views show subsets of results. Three refers to the model alternatives rather than the catalogue size.</a:t>
             </a:r>
           </a:p>
           <a:p xmlns:a="http://schemas.openxmlformats.org/drawingml/2006/main">
@@ -2167,7 +2167,7 @@
           </a:p>
           <a:p xmlns:a="http://schemas.openxmlformats.org/drawingml/2006/main">
             <a:r>
-              <a:t>The image shows a real session diagnostic, not a new benchmark or attention map.</a:t>
+              <a:t>This earlier actual Baby request screenshot is independent of the Model arena capture. It shows the first visible recommendation in each column, not every row of the Top 3. Each request uses the matching query and candidate encoder. The respective retrieved pools can differ. Product examples do not replace held-out relevance evaluation.</a:t>
             </a:r>
           </a:p>
           <a:p xmlns:a="http://schemas.openxmlformats.org/drawingml/2006/main">
@@ -2182,17 +2182,22 @@
           </a:p>
           <a:p xmlns:a="http://schemas.openxmlformats.org/drawingml/2006/main">
             <a:r>
-              <a:t>assets/research_heatmap.png</a:t>
-            </a:r>
-          </a:p>
-          <a:p xmlns:a="http://schemas.openxmlformats.org/drawingml/2006/main">
-            <a:r>
-              <a:t>src/shoplens/visual_ui.py</a:t>
-            </a:r>
-          </a:p>
-          <a:p xmlns:a="http://schemas.openxmlformats.org/drawingml/2006/main">
-            <a:r>
-              <a:t>src/shoplens/visual_charts.py</a:t>
+              <a:t>assets/studio_models.jpg</a:t>
+            </a:r>
+          </a:p>
+          <a:p xmlns:a="http://schemas.openxmlformats.org/drawingml/2006/main">
+            <a:r>
+              <a:t>src/shoplens/studio_ui.py</a:t>
+            </a:r>
+          </a:p>
+          <a:p xmlns:a="http://schemas.openxmlformats.org/drawingml/2006/main">
+            <a:r>
+              <a:t>src/shoplens/studio_encoders.py</a:t>
+            </a:r>
+          </a:p>
+          <a:p xmlns:a="http://schemas.openxmlformats.org/drawingml/2006/main">
+            <a:r>
+              <a:t>src/shoplens/studio_models.py</a:t>
             </a:r>
           </a:p>
         </p:txBody>
@@ -2262,7 +2267,7 @@
           <a:lstStyle xmlns:a="http://schemas.openxmlformats.org/drawingml/2006/main"/>
           <a:p xmlns:a="http://schemas.openxmlformats.org/drawingml/2006/main">
             <a:r>
-              <a:t>Optional discussion: the experiment dashboard exposes saved training traces and selection evidence. The public demonstration uses the selected seed-forty-two exports, while aggregate results retain all three formal seeds. The plotted trace describes the recorded run. Its appearance is not a new performance claim.</a:t>
+              <a:t>Optional discussion: Experiment gallery displays the two recorded adaptation-epoch validation results for each arm. In Sports seed forty-four, all three models select epoch one. The rings mark those choices. Lines connect actual saved observations and do not show unrecorded optimization steps. Test results never choose the epoch.</a:t>
             </a:r>
           </a:p>
           <a:p xmlns:a="http://schemas.openxmlformats.org/drawingml/2006/main">
@@ -2277,7 +2282,7 @@
           </a:p>
           <a:p xmlns:a="http://schemas.openxmlformats.org/drawingml/2006/main">
             <a:r>
-              <a:t>The displayed Baby semantic seed42 trace selects adaptation epoch 2 using 30,000 examples. The line is adaptation_curve/validation_ndcg@10, not test performance. Across the study, all three groups select adaptation epoch 1 or 2 by full-catalogue validation NDCG@10. Existing aggregate results and original baseline results remain separate.</a:t>
+              <a:t>Actual validation NDCG@10: Frozen epoch1 0.01039775584130691, epoch2 0.00887591995099229. Semantic epoch1 0.008968238048314637, epoch2 0.008466524502734576. Preference epoch1 0.010366837105701692, epoch2 0.008324549533718625. All select epoch1. Across the formal study, full-catalogue validation selects epoch1 or2. Frozen keeps its text encoder fixed while its recommendation head still trains. This Sports seed44 example differs from Studio’s selected seed42 serving models. dist/experiment-gallery is an optional separately generated or downloaded offline export folder, not a claim that generated files belong to the Git source tree.</a:t>
             </a:r>
           </a:p>
           <a:p xmlns:a="http://schemas.openxmlformats.org/drawingml/2006/main">
@@ -2292,17 +2297,27 @@
           </a:p>
           <a:p xmlns:a="http://schemas.openxmlformats.org/drawingml/2006/main">
             <a:r>
-              <a:t>assets/research_training.png</a:t>
-            </a:r>
-          </a:p>
-          <a:p xmlns:a="http://schemas.openxmlformats.org/drawingml/2006/main">
-            <a:r>
-              <a:t>src/shoplens/ui.py</a:t>
-            </a:r>
-          </a:p>
-          <a:p xmlns:a="http://schemas.openxmlformats.org/drawingml/2006/main">
-            <a:r>
-              <a:t>artifacts/qwen/baby/qwen_semantic/seed42/training.json</a:t>
+              <a:t>assets/experiment_training_sports_seed44.png</a:t>
+            </a:r>
+          </a:p>
+          <a:p xmlns:a="http://schemas.openxmlformats.org/drawingml/2006/main">
+            <a:r>
+              <a:t>src/shoplens/experiment_charts.py</a:t>
+            </a:r>
+          </a:p>
+          <a:p xmlns:a="http://schemas.openxmlformats.org/drawingml/2006/main">
+            <a:r>
+              <a:t>submission/results_qwen_summary.json</a:t>
+            </a:r>
+          </a:p>
+          <a:p xmlns:a="http://schemas.openxmlformats.org/drawingml/2006/main">
+            <a:r>
+              <a:t>scripts/export_experiment_gallery.py</a:t>
+            </a:r>
+          </a:p>
+          <a:p xmlns:a="http://schemas.openxmlformats.org/drawingml/2006/main">
+            <a:r>
+              <a:t>dist/experiment-gallery/training_curves.csv</a:t>
             </a:r>
           </a:p>
         </p:txBody>
@@ -2372,7 +2387,7 @@
           <a:lstStyle xmlns:a="http://schemas.openxmlformats.org/drawingml/2006/main"/>
           <a:p xmlns:a="http://schemas.openxmlformats.org/drawingml/2006/main">
             <a:r>
-              <a:t>Optional discussion: the speaker notes contain primary source links and project-relative evidence references. The team should record a real human presentation, complete genuine contribution statements and review the AI disclosure before submission.</a:t>
+              <a:t>Optional discussion: primary sources establish the data and model methods. The English experiment report and audited summary describe the formal study. Source code exposes the application and gallery calculations. The export script produces a standalone offline gallery with seven interactive figures, the plotted CSV values and structured evidence JSON.</a:t>
             </a:r>
           </a:p>
           <a:p xmlns:a="http://schemas.openxmlformats.org/drawingml/2006/main">
@@ -2387,7 +2402,7 @@
           </a:p>
           <a:p xmlns:a="http://schemas.openxmlformats.org/drawingml/2006/main">
             <a:r>
-              <a:t>Public release preparation is separate from a completed code submission. No private account, machine path, operational log or user-level review data is required to explain the work.</a:t>
+              <a:t>Resolve src/..., scripts/..., submission/..., data/..., artifacts/... and dist/... from the repository root. Resolve assets/... relative to submission/. Runtime data and model artifacts require a separate runtime installation. The optional dist/experiment-gallery folder is generated by the export script or supplied as a separate offline export package. Its seven figures are four performance metrics, the paired seed matrix, paired effect summary and validation dynamics. The HTML embeds Plotly locally. This is presentation and export of the existing 27 evaluations, without retraining or new relevance measurements.</a:t>
             </a:r>
           </a:p>
           <a:p xmlns:a="http://schemas.openxmlformats.org/drawingml/2006/main">
@@ -2427,12 +2442,32 @@
           </a:p>
           <a:p xmlns:a="http://schemas.openxmlformats.org/drawingml/2006/main">
             <a:r>
+              <a:t>submission/ShopLens_Qwen_report_en.md</a:t>
+            </a:r>
+          </a:p>
+          <a:p xmlns:a="http://schemas.openxmlformats.org/drawingml/2006/main">
+            <a:r>
               <a:t>submission/results_qwen_summary.json</a:t>
             </a:r>
           </a:p>
           <a:p xmlns:a="http://schemas.openxmlformats.org/drawingml/2006/main">
             <a:r>
-              <a:t>submission/ShopLens_Qwen_AI_disclosure_draft.md</a:t>
+              <a:t>src/shoplens/experiment_data.py</a:t>
+            </a:r>
+          </a:p>
+          <a:p xmlns:a="http://schemas.openxmlformats.org/drawingml/2006/main">
+            <a:r>
+              <a:t>src/shoplens/experiment_charts.py</a:t>
+            </a:r>
+          </a:p>
+          <a:p xmlns:a="http://schemas.openxmlformats.org/drawingml/2006/main">
+            <a:r>
+              <a:t>scripts/export_experiment_gallery.py</a:t>
+            </a:r>
+          </a:p>
+          <a:p xmlns:a="http://schemas.openxmlformats.org/drawingml/2006/main">
+            <a:r>
+              <a:t>dist/experiment-gallery/index.html</a:t>
             </a:r>
           </a:p>
         </p:txBody>
@@ -2502,7 +2537,7 @@
           <a:lstStyle xmlns:a="http://schemas.openxmlformats.org/drawingml/2006/main"/>
           <a:p xmlns:a="http://schemas.openxmlformats.org/drawingml/2006/main">
             <a:r>
-              <a:t>The data contains real product text, reviews and photographs across Baby, Sports and Clothing. We split chronologically and use only strictly earlier positive history. Ranking covers the full prepared catalogue, excluding previous positives. Metrics first average targets within users. These are three domains from one Amazon source, which the instructor still needs to accept as the dataset requirement.</a:t>
+              <a:t>The data contains real product text, reviews and photographs across Baby, Sports and Clothing. We split chronologically and use only strictly earlier positive history. Ranking covers the full prepared catalogue, excluding previous positives. Metrics first average targets within users. These are three domains from one Amazon source, which limits evidence about cross-source generalization.</a:t>
             </a:r>
           </a:p>
           <a:p xmlns:a="http://schemas.openxmlformats.org/drawingml/2006/main">
@@ -2937,7 +2972,7 @@
           <a:lstStyle xmlns:a="http://schemas.openxmlformats.org/drawingml/2006/main"/>
           <a:p xmlns:a="http://schemas.openxmlformats.org/drawingml/2006/main">
             <a:r>
-              <a:t>The Research lab keeps the matched seed differences visible. We inspect paired changes against Frozen rather than selecting the best run. Three seeds provide limited evidence about variability. A positive bar is an observed difference, not statistical significance. The negative results stay in the report and interface.</a:t>
+              <a:t>Experiment gallery exposes the original twenty-seven evaluations through metric, paired-seed and training views. This matrix contains eighteen same-seed differences against Frozen, including losses. The three columns show all recorded seeds. The gallery adds inspection and export, while the evidence remains the same controlled study.</a:t>
             </a:r>
           </a:p>
           <a:p xmlns:a="http://schemas.openxmlformats.org/drawingml/2006/main">
@@ -2947,22 +2982,42 @@
           </a:p>
           <a:p xmlns:a="http://schemas.openxmlformats.org/drawingml/2006/main">
             <a:r>
+              <a:t>Discussion notes</a:t>
+            </a:r>
+          </a:p>
+          <a:p xmlns:a="http://schemas.openxmlformats.org/drawingml/2006/main">
+            <a:r>
+              <a:t>Each cell subtracts the Frozen test NDCG@10 for the same domain and seed. Semantic alignment wins 2 of 9 pairs and user preference wins 3 of 9. Three seeds, sample standard deviation and observed signs do not establish statistical significance. This feature displays existing runs and does not add a new experiment.</a:t>
+            </a:r>
+          </a:p>
+          <a:p xmlns:a="http://schemas.openxmlformats.org/drawingml/2006/main">
+            <a:r>
+              <a:t/>
+            </a:r>
+          </a:p>
+          <a:p xmlns:a="http://schemas.openxmlformats.org/drawingml/2006/main">
+            <a:r>
               <a:t>Sources</a:t>
             </a:r>
           </a:p>
           <a:p xmlns:a="http://schemas.openxmlformats.org/drawingml/2006/main">
             <a:r>
-              <a:t>assets/research_paired.png</a:t>
-            </a:r>
-          </a:p>
-          <a:p xmlns:a="http://schemas.openxmlformats.org/drawingml/2006/main">
-            <a:r>
-              <a:t>src/shoplens/visual_charts.py</a:t>
-            </a:r>
-          </a:p>
-          <a:p xmlns:a="http://schemas.openxmlformats.org/drawingml/2006/main">
-            <a:r>
-              <a:t>src/shoplens/ui.py</a:t>
+              <a:t>assets/experiment_paired_matrix.png</a:t>
+            </a:r>
+          </a:p>
+          <a:p xmlns:a="http://schemas.openxmlformats.org/drawingml/2006/main">
+            <a:r>
+              <a:t>src/shoplens/experiment_ui.py</a:t>
+            </a:r>
+          </a:p>
+          <a:p xmlns:a="http://schemas.openxmlformats.org/drawingml/2006/main">
+            <a:r>
+              <a:t>src/shoplens/experiment_data.py</a:t>
+            </a:r>
+          </a:p>
+          <a:p xmlns:a="http://schemas.openxmlformats.org/drawingml/2006/main">
+            <a:r>
+              <a:t>src/shoplens/experiment_charts.py</a:t>
             </a:r>
           </a:p>
           <a:p xmlns:a="http://schemas.openxmlformats.org/drawingml/2006/main">
@@ -3132,7 +3187,7 @@
           <a:lstStyle xmlns:a="http://schemas.openxmlformats.org/drawingml/2006/main"/>
           <a:p xmlns:a="http://schemas.openxmlformats.org/drawingml/2006/main">
             <a:r>
-              <a:t>The same stroller request runs through all three selected checkpoints. Each arm encodes the query in the same space as its candidate text vectors. The comparison shows actual products, overlap and observed ranks. The respective candidate pools can differ. This is exploratory request retrieval, separate from the controlled history-based test.</a:t>
+              <a:t>Model arena follows one actual stroller across the three request lists. Frozen places it fifth, Semantic first and Preference sixth. Each query matches its candidate space, without positive feedback. The three Top-twelve lists contain twenty-four unique products. These differences reveal disagreement, with no relevance labels to establish which model is better.</a:t>
             </a:r>
           </a:p>
           <a:p xmlns:a="http://schemas.openxmlformats.org/drawingml/2006/main">
@@ -3147,7 +3202,7 @@
           </a:p>
           <a:p xmlns:a="http://schemas.openxmlformats.org/drawingml/2006/main">
             <a:r>
-              <a:t>The example uses no positive feedback. Current Studio retrieves each model's own top 200 text-similar candidates, including boundary ties. Missing Top-K ranks stay unknown. Raw Studio scores are not compared across models.</a:t>
+              <a:t>The actual query is Find a stroller for everyday outings. Dream On Me / Mia Moda Veloce Stroller, Mint Java is ASIN B002UHJ0HK. The observed union contains 24 unique items, with 2 in all three lists, 8 in exactly two and 14 in exactly one. Each model retrieves its own top 200 text-similar candidates, including boundary ties. This application example is exploratory request retrieval, separate from the formal history-to-item test. A missing Top-K position remains unknown. Raw scores are not compared across models.</a:t>
             </a:r>
           </a:p>
           <a:p xmlns:a="http://schemas.openxmlformats.org/drawingml/2006/main">
@@ -3162,7 +3217,7 @@
           </a:p>
           <a:p xmlns:a="http://schemas.openxmlformats.org/drawingml/2006/main">
             <a:r>
-              <a:t>assets/studio_models.jpg</a:t>
+              <a:t>assets/studio_model_arena.png</a:t>
             </a:r>
           </a:p>
           <a:p xmlns:a="http://schemas.openxmlformats.org/drawingml/2006/main">
@@ -3178,6 +3233,11 @@
           <a:p xmlns:a="http://schemas.openxmlformats.org/drawingml/2006/main">
             <a:r>
               <a:t>src/shoplens/studio_ui.py</a:t>
+            </a:r>
+          </a:p>
+          <a:p xmlns:a="http://schemas.openxmlformats.org/drawingml/2006/main">
+            <a:r>
+              <a:t>src/shoplens/studio_charts.py</a:t>
             </a:r>
           </a:p>
         </p:txBody>
@@ -19756,6 +19816,7 @@
               </a:defRPr>
             </a:defPPr>
             <a:lvl1pPr>
+              <a:buNone/>
               <a:defRPr sz="3075" b="1">
                 <a:solidFill>
                   <a:srgbClr val="17243C"/>
@@ -19766,6 +19827,7 @@
               </a:defRPr>
             </a:lvl1pPr>
             <a:lvl2pPr>
+              <a:buNone/>
               <a:defRPr sz="3075" b="1">
                 <a:solidFill>
                   <a:srgbClr val="17243C"/>
@@ -19776,6 +19838,7 @@
               </a:defRPr>
             </a:lvl2pPr>
             <a:lvl3pPr>
+              <a:buNone/>
               <a:defRPr sz="3075" b="1">
                 <a:solidFill>
                   <a:srgbClr val="17243C"/>
@@ -19786,6 +19849,7 @@
               </a:defRPr>
             </a:lvl3pPr>
             <a:lvl4pPr>
+              <a:buNone/>
               <a:defRPr sz="3075" b="1">
                 <a:solidFill>
                   <a:srgbClr val="17243C"/>
@@ -19796,6 +19860,7 @@
               </a:defRPr>
             </a:lvl4pPr>
             <a:lvl5pPr>
+              <a:buNone/>
               <a:defRPr sz="3075" b="1">
                 <a:solidFill>
                   <a:srgbClr val="17243C"/>
@@ -19806,6 +19871,7 @@
               </a:defRPr>
             </a:lvl5pPr>
             <a:lvl6pPr>
+              <a:buNone/>
               <a:defRPr sz="3075" b="1">
                 <a:solidFill>
                   <a:srgbClr val="17243C"/>
@@ -19816,6 +19882,7 @@
               </a:defRPr>
             </a:lvl6pPr>
             <a:lvl7pPr>
+              <a:buNone/>
               <a:defRPr sz="3075" b="1">
                 <a:solidFill>
                   <a:srgbClr val="17243C"/>
@@ -19826,6 +19893,7 @@
               </a:defRPr>
             </a:lvl7pPr>
             <a:lvl8pPr>
+              <a:buNone/>
               <a:defRPr sz="3075" b="1">
                 <a:solidFill>
                   <a:srgbClr val="17243C"/>
@@ -19836,6 +19904,7 @@
               </a:defRPr>
             </a:lvl8pPr>
             <a:lvl9pPr>
+              <a:buNone/>
               <a:defRPr sz="3075" b="1">
                 <a:solidFill>
                   <a:srgbClr val="17243C"/>
@@ -19848,6 +19917,7 @@
           </a:lstStyle>
           <a:p xmlns:a="http://schemas.openxmlformats.org/drawingml/2006/main">
             <a:pPr>
+              <a:buNone/>
               <a:defRPr sz="3075" b="1">
                 <a:solidFill>
                   <a:srgbClr val="17243C"/>
@@ -19866,7 +19936,7 @@
                 <a:ea typeface="Helvetica Neue"/>
                 <a:cs typeface="Helvetica Neue"/>
               </a:rPr>
-              <a:t>Appendix 6. Similarity heatmap</a:t>
+              <a:t>Appendix 6. Product lists from three models</a:t>
             </a:r>
           </a:p>
         </p:txBody>
@@ -19914,6 +19984,7 @@
               </a:defRPr>
             </a:defPPr>
             <a:lvl1pPr algn="r">
+              <a:buNone/>
               <a:defRPr sz="1275" b="0">
                 <a:solidFill>
                   <a:srgbClr val="586C7C"/>
@@ -19924,6 +19995,7 @@
               </a:defRPr>
             </a:lvl1pPr>
             <a:lvl2pPr algn="r">
+              <a:buNone/>
               <a:defRPr sz="1275" b="0">
                 <a:solidFill>
                   <a:srgbClr val="586C7C"/>
@@ -19934,6 +20006,7 @@
               </a:defRPr>
             </a:lvl2pPr>
             <a:lvl3pPr algn="r">
+              <a:buNone/>
               <a:defRPr sz="1275" b="0">
                 <a:solidFill>
                   <a:srgbClr val="586C7C"/>
@@ -19944,6 +20017,7 @@
               </a:defRPr>
             </a:lvl3pPr>
             <a:lvl4pPr algn="r">
+              <a:buNone/>
               <a:defRPr sz="1275" b="0">
                 <a:solidFill>
                   <a:srgbClr val="586C7C"/>
@@ -19954,6 +20028,7 @@
               </a:defRPr>
             </a:lvl4pPr>
             <a:lvl5pPr algn="r">
+              <a:buNone/>
               <a:defRPr sz="1275" b="0">
                 <a:solidFill>
                   <a:srgbClr val="586C7C"/>
@@ -19964,6 +20039,7 @@
               </a:defRPr>
             </a:lvl5pPr>
             <a:lvl6pPr algn="r">
+              <a:buNone/>
               <a:defRPr sz="1275" b="0">
                 <a:solidFill>
                   <a:srgbClr val="586C7C"/>
@@ -19974,6 +20050,7 @@
               </a:defRPr>
             </a:lvl6pPr>
             <a:lvl7pPr algn="r">
+              <a:buNone/>
               <a:defRPr sz="1275" b="0">
                 <a:solidFill>
                   <a:srgbClr val="586C7C"/>
@@ -19984,6 +20061,7 @@
               </a:defRPr>
             </a:lvl7pPr>
             <a:lvl8pPr algn="r">
+              <a:buNone/>
               <a:defRPr sz="1275" b="0">
                 <a:solidFill>
                   <a:srgbClr val="586C7C"/>
@@ -19994,6 +20072,7 @@
               </a:defRPr>
             </a:lvl8pPr>
             <a:lvl9pPr algn="r">
+              <a:buNone/>
               <a:defRPr sz="1275" b="0">
                 <a:solidFill>
                   <a:srgbClr val="586C7C"/>
@@ -20006,6 +20085,7 @@
           </a:lstStyle>
           <a:p xmlns:a="http://schemas.openxmlformats.org/drawingml/2006/main">
             <a:pPr algn="r">
+              <a:buNone/>
               <a:defRPr sz="1275" b="0">
                 <a:solidFill>
                   <a:srgbClr val="586C7C"/>
@@ -20034,7 +20114,7 @@
           <p:cNvPr id="3" name="">
             <a:extLst xmlns:a="http://schemas.openxmlformats.org/drawingml/2006/main">
               <a:ext uri="{FF2B5EF4-FFF2-40B4-BE49-F238E27FC236}">
-                <a16:creationId xmlns:a16="http://schemas.microsoft.com/office/drawing/2014/main" id="{CB280CC0-3256-4FED-9D48-8610554D4619}"/>
+                <a16:creationId xmlns:a16="http://schemas.microsoft.com/office/drawing/2014/main" id="{BBCE460E-E1C4-4FB5-815E-5C471DD6ED05}"/>
               </a:ext>
             </a:extLst>
           </p:cNvPr>
@@ -20044,14 +20124,14 @@
           <p:nvPr/>
         </p:nvPicPr>
         <p:blipFill>
-          <a:blip xmlns:r="http://schemas.openxmlformats.org/officeDocument/2006/relationships" xmlns:a="http://schemas.openxmlformats.org/drawingml/2006/main" r:embed="Rced5e0af750b4150"/>
-          <a:srcRect xmlns:a="http://schemas.openxmlformats.org/drawingml/2006/main" l="2000" t="14500" r="2000" b="32500"/>
+          <a:blip xmlns:r="http://schemas.openxmlformats.org/officeDocument/2006/relationships" xmlns:a="http://schemas.openxmlformats.org/drawingml/2006/main" r:embed="Rab5ede6cc47f4092"/>
+          <a:srcRect xmlns:a="http://schemas.openxmlformats.org/drawingml/2006/main" l="25000" t="45000" r="4000" b="500"/>
           <a:stretch xmlns:a="http://schemas.openxmlformats.org/drawingml/2006/main"/>
         </p:blipFill>
         <p:spPr>
           <a:xfrm xmlns:a="http://schemas.openxmlformats.org/drawingml/2006/main">
-            <a:off x="1796031" y="1485900"/>
-            <a:ext cx="8599938" cy="4457700"/>
+            <a:off x="1914759" y="1485900"/>
+            <a:ext cx="8362482" cy="4457700"/>
           </a:xfrm>
           <a:prstGeom xmlns:a="http://schemas.openxmlformats.org/drawingml/2006/main" prst="rect">
             <a:avLst/>
@@ -20074,8 +20154,8 @@
         </p:nvSpPr>
         <p:spPr>
           <a:xfrm xmlns:a="http://schemas.openxmlformats.org/drawingml/2006/main">
-            <a:off x="628650" y="6057900"/>
-            <a:ext cx="10839450" cy="304800"/>
+            <a:off x="628650" y="6000750"/>
+            <a:ext cx="10839450" cy="514350"/>
           </a:xfrm>
           <a:prstGeom xmlns:a="http://schemas.openxmlformats.org/drawingml/2006/main" prst="rect">
             <a:avLst/>
@@ -20101,6 +20181,7 @@
               </a:defRPr>
             </a:defPPr>
             <a:lvl1pPr>
+              <a:buNone/>
               <a:defRPr sz="1650" b="0">
                 <a:solidFill>
                   <a:srgbClr val="586C7C"/>
@@ -20111,6 +20192,7 @@
               </a:defRPr>
             </a:lvl1pPr>
             <a:lvl2pPr>
+              <a:buNone/>
               <a:defRPr sz="1650" b="0">
                 <a:solidFill>
                   <a:srgbClr val="586C7C"/>
@@ -20121,6 +20203,7 @@
               </a:defRPr>
             </a:lvl2pPr>
             <a:lvl3pPr>
+              <a:buNone/>
               <a:defRPr sz="1650" b="0">
                 <a:solidFill>
                   <a:srgbClr val="586C7C"/>
@@ -20131,6 +20214,7 @@
               </a:defRPr>
             </a:lvl3pPr>
             <a:lvl4pPr>
+              <a:buNone/>
               <a:defRPr sz="1650" b="0">
                 <a:solidFill>
                   <a:srgbClr val="586C7C"/>
@@ -20141,6 +20225,7 @@
               </a:defRPr>
             </a:lvl4pPr>
             <a:lvl5pPr>
+              <a:buNone/>
               <a:defRPr sz="1650" b="0">
                 <a:solidFill>
                   <a:srgbClr val="586C7C"/>
@@ -20151,6 +20236,7 @@
               </a:defRPr>
             </a:lvl5pPr>
             <a:lvl6pPr>
+              <a:buNone/>
               <a:defRPr sz="1650" b="0">
                 <a:solidFill>
                   <a:srgbClr val="586C7C"/>
@@ -20161,6 +20247,7 @@
               </a:defRPr>
             </a:lvl6pPr>
             <a:lvl7pPr>
+              <a:buNone/>
               <a:defRPr sz="1650" b="0">
                 <a:solidFill>
                   <a:srgbClr val="586C7C"/>
@@ -20171,6 +20258,7 @@
               </a:defRPr>
             </a:lvl7pPr>
             <a:lvl8pPr>
+              <a:buNone/>
               <a:defRPr sz="1650" b="0">
                 <a:solidFill>
                   <a:srgbClr val="586C7C"/>
@@ -20181,6 +20269,7 @@
               </a:defRPr>
             </a:lvl8pPr>
             <a:lvl9pPr>
+              <a:buNone/>
               <a:defRPr sz="1650" b="0">
                 <a:solidFill>
                   <a:srgbClr val="586C7C"/>
@@ -20193,6 +20282,7 @@
           </a:lstStyle>
           <a:p xmlns:a="http://schemas.openxmlformats.org/drawingml/2006/main">
             <a:pPr>
+              <a:buNone/>
               <a:defRPr sz="1650" b="0">
                 <a:solidFill>
                   <a:srgbClr val="586C7C"/>
@@ -20211,7 +20301,189 @@
                 <a:ea typeface="Helvetica Neue"/>
                 <a:cs typeface="Helvetica Neue"/>
               </a:rPr>
-              <a:t>The diverging scale retains negative values and centers on zero.</a:t>
+              <a:t>Baby has 7,037 products. Shown: each model’s first recommendation.</a:t>
+            </a:r>
+          </a:p>
+          <a:p xmlns:a="http://schemas.openxmlformats.org/drawingml/2006/main">
+            <a:pPr>
+              <a:buNone/>
+              <a:defRPr sz="1650" b="0">
+                <a:solidFill>
+                  <a:srgbClr val="586C7C"/>
+                </a:solidFill>
+                <a:latin typeface="Helvetica Neue"/>
+                <a:ea typeface="Helvetica Neue"/>
+                <a:cs typeface="Helvetica Neue"/>
+              </a:defRPr>
+            </a:pPr>
+            <a:r>
+              <a:rPr sz="1650" b="0">
+                <a:solidFill>
+                  <a:srgbClr val="586C7C"/>
+                </a:solidFill>
+                <a:latin typeface="Helvetica Neue"/>
+                <a:ea typeface="Helvetica Neue"/>
+                <a:cs typeface="Helvetica Neue"/>
+              </a:rPr>
+              <a:t>Top 12 is a display subset. Three models do not mean three catalogue products.</a:t>
+            </a:r>
+          </a:p>
+        </p:txBody>
+      </p:sp>
+      <p:sp>
+        <p:nvSpPr>
+          <p:cNvPr id="6" name="">
+            <a:extLst xmlns:a="http://schemas.openxmlformats.org/drawingml/2006/main">
+              <a:ext uri="{FF2B5EF4-FFF2-40B4-BE49-F238E27FC236}">
+                <a16:creationId xmlns:a16="http://schemas.microsoft.com/office/drawing/2014/main" id="{638B83BF-78CE-45CF-9BDE-E14D9F2516A2}"/>
+              </a:ext>
+            </a:extLst>
+          </p:cNvPr>
+          <p:cNvSpPr>
+            <a:spLocks xmlns:a="http://schemas.openxmlformats.org/drawingml/2006/main" noGrp="1"/>
+          </p:cNvSpPr>
+          <p:nvPr/>
+        </p:nvSpPr>
+        <p:spPr>
+          <a:xfrm xmlns:a="http://schemas.openxmlformats.org/drawingml/2006/main">
+            <a:off x="628650" y="1057275"/>
+            <a:ext cx="10934700" cy="609600"/>
+          </a:xfrm>
+          <a:prstGeom xmlns:a="http://schemas.openxmlformats.org/drawingml/2006/main" prst="rect">
+            <a:avLst/>
+          </a:prstGeom>
+          <a:noFill xmlns:a="http://schemas.openxmlformats.org/drawingml/2006/main"/>
+          <a:ln xmlns:a="http://schemas.openxmlformats.org/drawingml/2006/main" w="0">
+            <a:noFill/>
+          </a:ln>
+        </p:spPr>
+        <p:txBody>
+          <a:bodyPr xmlns:a="http://schemas.openxmlformats.org/drawingml/2006/main" wrap="square" lIns="0" tIns="0" rIns="0" bIns="0" anchor="t">
+            <a:noAutofit/>
+          </a:bodyPr>
+          <a:lstStyle xmlns:a="http://schemas.openxmlformats.org/drawingml/2006/main">
+            <a:defPPr>
+              <a:defRPr sz="1800" b="0">
+                <a:solidFill>
+                  <a:srgbClr val="586C7C"/>
+                </a:solidFill>
+                <a:latin typeface="Helvetica Neue"/>
+                <a:ea typeface="Helvetica Neue"/>
+                <a:cs typeface="Helvetica Neue"/>
+              </a:defRPr>
+            </a:defPPr>
+            <a:lvl1pPr>
+              <a:defRPr sz="1800" b="0">
+                <a:solidFill>
+                  <a:srgbClr val="586C7C"/>
+                </a:solidFill>
+                <a:latin typeface="Helvetica Neue"/>
+                <a:ea typeface="Helvetica Neue"/>
+                <a:cs typeface="Helvetica Neue"/>
+              </a:defRPr>
+            </a:lvl1pPr>
+            <a:lvl2pPr>
+              <a:defRPr sz="1800" b="0">
+                <a:solidFill>
+                  <a:srgbClr val="586C7C"/>
+                </a:solidFill>
+                <a:latin typeface="Helvetica Neue"/>
+                <a:ea typeface="Helvetica Neue"/>
+                <a:cs typeface="Helvetica Neue"/>
+              </a:defRPr>
+            </a:lvl2pPr>
+            <a:lvl3pPr>
+              <a:defRPr sz="1800" b="0">
+                <a:solidFill>
+                  <a:srgbClr val="586C7C"/>
+                </a:solidFill>
+                <a:latin typeface="Helvetica Neue"/>
+                <a:ea typeface="Helvetica Neue"/>
+                <a:cs typeface="Helvetica Neue"/>
+              </a:defRPr>
+            </a:lvl3pPr>
+            <a:lvl4pPr>
+              <a:defRPr sz="1800" b="0">
+                <a:solidFill>
+                  <a:srgbClr val="586C7C"/>
+                </a:solidFill>
+                <a:latin typeface="Helvetica Neue"/>
+                <a:ea typeface="Helvetica Neue"/>
+                <a:cs typeface="Helvetica Neue"/>
+              </a:defRPr>
+            </a:lvl4pPr>
+            <a:lvl5pPr>
+              <a:defRPr sz="1800" b="0">
+                <a:solidFill>
+                  <a:srgbClr val="586C7C"/>
+                </a:solidFill>
+                <a:latin typeface="Helvetica Neue"/>
+                <a:ea typeface="Helvetica Neue"/>
+                <a:cs typeface="Helvetica Neue"/>
+              </a:defRPr>
+            </a:lvl5pPr>
+            <a:lvl6pPr>
+              <a:defRPr sz="1800" b="0">
+                <a:solidFill>
+                  <a:srgbClr val="586C7C"/>
+                </a:solidFill>
+                <a:latin typeface="Helvetica Neue"/>
+                <a:ea typeface="Helvetica Neue"/>
+                <a:cs typeface="Helvetica Neue"/>
+              </a:defRPr>
+            </a:lvl6pPr>
+            <a:lvl7pPr>
+              <a:defRPr sz="1800" b="0">
+                <a:solidFill>
+                  <a:srgbClr val="586C7C"/>
+                </a:solidFill>
+                <a:latin typeface="Helvetica Neue"/>
+                <a:ea typeface="Helvetica Neue"/>
+                <a:cs typeface="Helvetica Neue"/>
+              </a:defRPr>
+            </a:lvl7pPr>
+            <a:lvl8pPr>
+              <a:defRPr sz="1800" b="0">
+                <a:solidFill>
+                  <a:srgbClr val="586C7C"/>
+                </a:solidFill>
+                <a:latin typeface="Helvetica Neue"/>
+                <a:ea typeface="Helvetica Neue"/>
+                <a:cs typeface="Helvetica Neue"/>
+              </a:defRPr>
+            </a:lvl8pPr>
+            <a:lvl9pPr>
+              <a:defRPr sz="1800" b="0">
+                <a:solidFill>
+                  <a:srgbClr val="586C7C"/>
+                </a:solidFill>
+                <a:latin typeface="Helvetica Neue"/>
+                <a:ea typeface="Helvetica Neue"/>
+                <a:cs typeface="Helvetica Neue"/>
+              </a:defRPr>
+            </a:lvl9pPr>
+          </a:lstStyle>
+          <a:p xmlns:a="http://schemas.openxmlformats.org/drawingml/2006/main">
+            <a:pPr>
+              <a:defRPr sz="1800" b="0">
+                <a:solidFill>
+                  <a:srgbClr val="586C7C"/>
+                </a:solidFill>
+                <a:latin typeface="Helvetica Neue"/>
+                <a:ea typeface="Helvetica Neue"/>
+                <a:cs typeface="Helvetica Neue"/>
+              </a:defRPr>
+            </a:pPr>
+            <a:r>
+              <a:rPr sz="1800" b="0">
+                <a:solidFill>
+                  <a:srgbClr val="586C7C"/>
+                </a:solidFill>
+                <a:latin typeface="Helvetica Neue"/>
+                <a:ea typeface="Helvetica Neue"/>
+                <a:cs typeface="Helvetica Neue"/>
+              </a:rPr>
+              <a:t>An earlier actual Baby request, with no positive feedback</a:t>
             </a:r>
           </a:p>
         </p:txBody>
@@ -20288,6 +20560,7 @@
               </a:defRPr>
             </a:defPPr>
             <a:lvl1pPr>
+              <a:buNone/>
               <a:defRPr sz="3075" b="1">
                 <a:solidFill>
                   <a:srgbClr val="17243C"/>
@@ -20298,6 +20571,7 @@
               </a:defRPr>
             </a:lvl1pPr>
             <a:lvl2pPr>
+              <a:buNone/>
               <a:defRPr sz="3075" b="1">
                 <a:solidFill>
                   <a:srgbClr val="17243C"/>
@@ -20308,6 +20582,7 @@
               </a:defRPr>
             </a:lvl2pPr>
             <a:lvl3pPr>
+              <a:buNone/>
               <a:defRPr sz="3075" b="1">
                 <a:solidFill>
                   <a:srgbClr val="17243C"/>
@@ -20318,6 +20593,7 @@
               </a:defRPr>
             </a:lvl3pPr>
             <a:lvl4pPr>
+              <a:buNone/>
               <a:defRPr sz="3075" b="1">
                 <a:solidFill>
                   <a:srgbClr val="17243C"/>
@@ -20328,6 +20604,7 @@
               </a:defRPr>
             </a:lvl4pPr>
             <a:lvl5pPr>
+              <a:buNone/>
               <a:defRPr sz="3075" b="1">
                 <a:solidFill>
                   <a:srgbClr val="17243C"/>
@@ -20338,6 +20615,7 @@
               </a:defRPr>
             </a:lvl5pPr>
             <a:lvl6pPr>
+              <a:buNone/>
               <a:defRPr sz="3075" b="1">
                 <a:solidFill>
                   <a:srgbClr val="17243C"/>
@@ -20348,6 +20626,7 @@
               </a:defRPr>
             </a:lvl6pPr>
             <a:lvl7pPr>
+              <a:buNone/>
               <a:defRPr sz="3075" b="1">
                 <a:solidFill>
                   <a:srgbClr val="17243C"/>
@@ -20358,6 +20637,7 @@
               </a:defRPr>
             </a:lvl7pPr>
             <a:lvl8pPr>
+              <a:buNone/>
               <a:defRPr sz="3075" b="1">
                 <a:solidFill>
                   <a:srgbClr val="17243C"/>
@@ -20368,6 +20648,7 @@
               </a:defRPr>
             </a:lvl8pPr>
             <a:lvl9pPr>
+              <a:buNone/>
               <a:defRPr sz="3075" b="1">
                 <a:solidFill>
                   <a:srgbClr val="17243C"/>
@@ -20380,6 +20661,7 @@
           </a:lstStyle>
           <a:p xmlns:a="http://schemas.openxmlformats.org/drawingml/2006/main">
             <a:pPr>
+              <a:buNone/>
               <a:defRPr sz="3075" b="1">
                 <a:solidFill>
                   <a:srgbClr val="17243C"/>
@@ -20398,7 +20680,7 @@
                 <a:ea typeface="Helvetica Neue"/>
                 <a:cs typeface="Helvetica Neue"/>
               </a:rPr>
-              <a:t>Appendix 7. Training traces and selected checkpoints</a:t>
+              <a:t>Appendix 7. Training dynamics</a:t>
             </a:r>
           </a:p>
         </p:txBody>
@@ -20446,6 +20728,7 @@
               </a:defRPr>
             </a:defPPr>
             <a:lvl1pPr algn="r">
+              <a:buNone/>
               <a:defRPr sz="1275" b="0">
                 <a:solidFill>
                   <a:srgbClr val="586C7C"/>
@@ -20456,6 +20739,7 @@
               </a:defRPr>
             </a:lvl1pPr>
             <a:lvl2pPr algn="r">
+              <a:buNone/>
               <a:defRPr sz="1275" b="0">
                 <a:solidFill>
                   <a:srgbClr val="586C7C"/>
@@ -20466,6 +20750,7 @@
               </a:defRPr>
             </a:lvl2pPr>
             <a:lvl3pPr algn="r">
+              <a:buNone/>
               <a:defRPr sz="1275" b="0">
                 <a:solidFill>
                   <a:srgbClr val="586C7C"/>
@@ -20476,6 +20761,7 @@
               </a:defRPr>
             </a:lvl3pPr>
             <a:lvl4pPr algn="r">
+              <a:buNone/>
               <a:defRPr sz="1275" b="0">
                 <a:solidFill>
                   <a:srgbClr val="586C7C"/>
@@ -20486,6 +20772,7 @@
               </a:defRPr>
             </a:lvl4pPr>
             <a:lvl5pPr algn="r">
+              <a:buNone/>
               <a:defRPr sz="1275" b="0">
                 <a:solidFill>
                   <a:srgbClr val="586C7C"/>
@@ -20496,6 +20783,7 @@
               </a:defRPr>
             </a:lvl5pPr>
             <a:lvl6pPr algn="r">
+              <a:buNone/>
               <a:defRPr sz="1275" b="0">
                 <a:solidFill>
                   <a:srgbClr val="586C7C"/>
@@ -20506,6 +20794,7 @@
               </a:defRPr>
             </a:lvl6pPr>
             <a:lvl7pPr algn="r">
+              <a:buNone/>
               <a:defRPr sz="1275" b="0">
                 <a:solidFill>
                   <a:srgbClr val="586C7C"/>
@@ -20516,6 +20805,7 @@
               </a:defRPr>
             </a:lvl7pPr>
             <a:lvl8pPr algn="r">
+              <a:buNone/>
               <a:defRPr sz="1275" b="0">
                 <a:solidFill>
                   <a:srgbClr val="586C7C"/>
@@ -20526,6 +20816,7 @@
               </a:defRPr>
             </a:lvl8pPr>
             <a:lvl9pPr algn="r">
+              <a:buNone/>
               <a:defRPr sz="1275" b="0">
                 <a:solidFill>
                   <a:srgbClr val="586C7C"/>
@@ -20538,6 +20829,7 @@
           </a:lstStyle>
           <a:p xmlns:a="http://schemas.openxmlformats.org/drawingml/2006/main">
             <a:pPr algn="r">
+              <a:buNone/>
               <a:defRPr sz="1275" b="0">
                 <a:solidFill>
                   <a:srgbClr val="586C7C"/>
@@ -20566,7 +20858,7 @@
           <p:cNvPr id="3" name="">
             <a:extLst xmlns:a="http://schemas.openxmlformats.org/drawingml/2006/main">
               <a:ext uri="{FF2B5EF4-FFF2-40B4-BE49-F238E27FC236}">
-                <a16:creationId xmlns:a16="http://schemas.microsoft.com/office/drawing/2014/main" id="{9D97B670-598D-4726-8EEE-873170041DA9}"/>
+                <a16:creationId xmlns:a16="http://schemas.microsoft.com/office/drawing/2014/main" id="{82F91D69-B50D-45A2-9698-0E8492479046}"/>
               </a:ext>
             </a:extLst>
           </p:cNvPr>
@@ -20576,14 +20868,14 @@
           <p:nvPr/>
         </p:nvPicPr>
         <p:blipFill>
-          <a:blip xmlns:r="http://schemas.openxmlformats.org/officeDocument/2006/relationships" xmlns:a="http://schemas.openxmlformats.org/drawingml/2006/main" r:embed="R93ccd45e7415467c"/>
-          <a:srcRect xmlns:a="http://schemas.openxmlformats.org/drawingml/2006/main" l="1500" t="35000" r="1500" b="5500"/>
+          <a:blip xmlns:r="http://schemas.openxmlformats.org/officeDocument/2006/relationships" xmlns:a="http://schemas.openxmlformats.org/drawingml/2006/main" r:embed="R70a7acd6c90b4041"/>
+          <a:srcRect xmlns:a="http://schemas.openxmlformats.org/drawingml/2006/main" l="6250" t="25789" r="6250" b="10322"/>
           <a:stretch xmlns:a="http://schemas.openxmlformats.org/drawingml/2006/main"/>
         </p:blipFill>
         <p:spPr>
           <a:xfrm xmlns:a="http://schemas.openxmlformats.org/drawingml/2006/main">
-            <a:off x="2225877" y="1485900"/>
-            <a:ext cx="7740246" cy="4457700"/>
+            <a:off x="669227" y="1485900"/>
+            <a:ext cx="10853547" cy="4457700"/>
           </a:xfrm>
           <a:prstGeom xmlns:a="http://schemas.openxmlformats.org/drawingml/2006/main" prst="rect">
             <a:avLst/>
@@ -20633,6 +20925,7 @@
               </a:defRPr>
             </a:defPPr>
             <a:lvl1pPr>
+              <a:buNone/>
               <a:defRPr sz="1650" b="0">
                 <a:solidFill>
                   <a:srgbClr val="586C7C"/>
@@ -20643,6 +20936,7 @@
               </a:defRPr>
             </a:lvl1pPr>
             <a:lvl2pPr>
+              <a:buNone/>
               <a:defRPr sz="1650" b="0">
                 <a:solidFill>
                   <a:srgbClr val="586C7C"/>
@@ -20653,6 +20947,7 @@
               </a:defRPr>
             </a:lvl2pPr>
             <a:lvl3pPr>
+              <a:buNone/>
               <a:defRPr sz="1650" b="0">
                 <a:solidFill>
                   <a:srgbClr val="586C7C"/>
@@ -20663,6 +20958,7 @@
               </a:defRPr>
             </a:lvl3pPr>
             <a:lvl4pPr>
+              <a:buNone/>
               <a:defRPr sz="1650" b="0">
                 <a:solidFill>
                   <a:srgbClr val="586C7C"/>
@@ -20673,6 +20969,7 @@
               </a:defRPr>
             </a:lvl4pPr>
             <a:lvl5pPr>
+              <a:buNone/>
               <a:defRPr sz="1650" b="0">
                 <a:solidFill>
                   <a:srgbClr val="586C7C"/>
@@ -20683,6 +20980,7 @@
               </a:defRPr>
             </a:lvl5pPr>
             <a:lvl6pPr>
+              <a:buNone/>
               <a:defRPr sz="1650" b="0">
                 <a:solidFill>
                   <a:srgbClr val="586C7C"/>
@@ -20693,6 +20991,7 @@
               </a:defRPr>
             </a:lvl6pPr>
             <a:lvl7pPr>
+              <a:buNone/>
               <a:defRPr sz="1650" b="0">
                 <a:solidFill>
                   <a:srgbClr val="586C7C"/>
@@ -20703,6 +21002,7 @@
               </a:defRPr>
             </a:lvl7pPr>
             <a:lvl8pPr>
+              <a:buNone/>
               <a:defRPr sz="1650" b="0">
                 <a:solidFill>
                   <a:srgbClr val="586C7C"/>
@@ -20713,6 +21013,7 @@
               </a:defRPr>
             </a:lvl8pPr>
             <a:lvl9pPr>
+              <a:buNone/>
               <a:defRPr sz="1650" b="0">
                 <a:solidFill>
                   <a:srgbClr val="586C7C"/>
@@ -20725,6 +21026,7 @@
           </a:lstStyle>
           <a:p xmlns:a="http://schemas.openxmlformats.org/drawingml/2006/main">
             <a:pPr>
+              <a:buNone/>
               <a:defRPr sz="1650" b="0">
                 <a:solidFill>
                   <a:srgbClr val="586C7C"/>
@@ -20743,11 +21045,12 @@
                 <a:ea typeface="Helvetica Neue"/>
                 <a:cs typeface="Helvetica Neue"/>
               </a:rPr>
-              <a:t>Baby Semantic, seed42: 30,000 adaptation examples. Selected epoch 2.</a:t>
+              <a:t>All three Sports seed44 models select epoch 1. Rings mark the selected checkpoints.</a:t>
             </a:r>
           </a:p>
           <a:p xmlns:a="http://schemas.openxmlformats.org/drawingml/2006/main">
             <a:pPr>
+              <a:buNone/>
               <a:defRPr sz="1650" b="0">
                 <a:solidFill>
                   <a:srgbClr val="586C7C"/>
@@ -20766,7 +21069,165 @@
                 <a:ea typeface="Helvetica Neue"/>
                 <a:cs typeface="Helvetica Neue"/>
               </a:rPr>
-              <a:t>Validation selects the checkpoint. Test scores do not select or tune the model.</a:t>
+              <a:t>Only two recorded validation epochs. Test metrics never select the checkpoint.</a:t>
+            </a:r>
+          </a:p>
+        </p:txBody>
+      </p:sp>
+      <p:sp>
+        <p:nvSpPr>
+          <p:cNvPr id="6" name="">
+            <a:extLst xmlns:a="http://schemas.openxmlformats.org/drawingml/2006/main">
+              <a:ext uri="{FF2B5EF4-FFF2-40B4-BE49-F238E27FC236}">
+                <a16:creationId xmlns:a16="http://schemas.microsoft.com/office/drawing/2014/main" id="{024B33D8-CC7E-4C0E-941B-E7E53A4A72A0}"/>
+              </a:ext>
+            </a:extLst>
+          </p:cNvPr>
+          <p:cNvSpPr>
+            <a:spLocks xmlns:a="http://schemas.openxmlformats.org/drawingml/2006/main" noGrp="1"/>
+          </p:cNvSpPr>
+          <p:nvPr/>
+        </p:nvSpPr>
+        <p:spPr>
+          <a:xfrm xmlns:a="http://schemas.openxmlformats.org/drawingml/2006/main">
+            <a:off x="628650" y="1057275"/>
+            <a:ext cx="10934700" cy="609600"/>
+          </a:xfrm>
+          <a:prstGeom xmlns:a="http://schemas.openxmlformats.org/drawingml/2006/main" prst="rect">
+            <a:avLst/>
+          </a:prstGeom>
+          <a:noFill xmlns:a="http://schemas.openxmlformats.org/drawingml/2006/main"/>
+          <a:ln xmlns:a="http://schemas.openxmlformats.org/drawingml/2006/main" w="0">
+            <a:noFill/>
+          </a:ln>
+        </p:spPr>
+        <p:txBody>
+          <a:bodyPr xmlns:a="http://schemas.openxmlformats.org/drawingml/2006/main" wrap="square" lIns="0" tIns="0" rIns="0" bIns="0" anchor="t">
+            <a:noAutofit/>
+          </a:bodyPr>
+          <a:lstStyle xmlns:a="http://schemas.openxmlformats.org/drawingml/2006/main">
+            <a:defPPr>
+              <a:defRPr sz="1800" b="0">
+                <a:solidFill>
+                  <a:srgbClr val="586C7C"/>
+                </a:solidFill>
+                <a:latin typeface="Helvetica Neue"/>
+                <a:ea typeface="Helvetica Neue"/>
+                <a:cs typeface="Helvetica Neue"/>
+              </a:defRPr>
+            </a:defPPr>
+            <a:lvl1pPr>
+              <a:defRPr sz="1800" b="0">
+                <a:solidFill>
+                  <a:srgbClr val="586C7C"/>
+                </a:solidFill>
+                <a:latin typeface="Helvetica Neue"/>
+                <a:ea typeface="Helvetica Neue"/>
+                <a:cs typeface="Helvetica Neue"/>
+              </a:defRPr>
+            </a:lvl1pPr>
+            <a:lvl2pPr>
+              <a:defRPr sz="1800" b="0">
+                <a:solidFill>
+                  <a:srgbClr val="586C7C"/>
+                </a:solidFill>
+                <a:latin typeface="Helvetica Neue"/>
+                <a:ea typeface="Helvetica Neue"/>
+                <a:cs typeface="Helvetica Neue"/>
+              </a:defRPr>
+            </a:lvl2pPr>
+            <a:lvl3pPr>
+              <a:defRPr sz="1800" b="0">
+                <a:solidFill>
+                  <a:srgbClr val="586C7C"/>
+                </a:solidFill>
+                <a:latin typeface="Helvetica Neue"/>
+                <a:ea typeface="Helvetica Neue"/>
+                <a:cs typeface="Helvetica Neue"/>
+              </a:defRPr>
+            </a:lvl3pPr>
+            <a:lvl4pPr>
+              <a:defRPr sz="1800" b="0">
+                <a:solidFill>
+                  <a:srgbClr val="586C7C"/>
+                </a:solidFill>
+                <a:latin typeface="Helvetica Neue"/>
+                <a:ea typeface="Helvetica Neue"/>
+                <a:cs typeface="Helvetica Neue"/>
+              </a:defRPr>
+            </a:lvl4pPr>
+            <a:lvl5pPr>
+              <a:defRPr sz="1800" b="0">
+                <a:solidFill>
+                  <a:srgbClr val="586C7C"/>
+                </a:solidFill>
+                <a:latin typeface="Helvetica Neue"/>
+                <a:ea typeface="Helvetica Neue"/>
+                <a:cs typeface="Helvetica Neue"/>
+              </a:defRPr>
+            </a:lvl5pPr>
+            <a:lvl6pPr>
+              <a:defRPr sz="1800" b="0">
+                <a:solidFill>
+                  <a:srgbClr val="586C7C"/>
+                </a:solidFill>
+                <a:latin typeface="Helvetica Neue"/>
+                <a:ea typeface="Helvetica Neue"/>
+                <a:cs typeface="Helvetica Neue"/>
+              </a:defRPr>
+            </a:lvl6pPr>
+            <a:lvl7pPr>
+              <a:defRPr sz="1800" b="0">
+                <a:solidFill>
+                  <a:srgbClr val="586C7C"/>
+                </a:solidFill>
+                <a:latin typeface="Helvetica Neue"/>
+                <a:ea typeface="Helvetica Neue"/>
+                <a:cs typeface="Helvetica Neue"/>
+              </a:defRPr>
+            </a:lvl7pPr>
+            <a:lvl8pPr>
+              <a:defRPr sz="1800" b="0">
+                <a:solidFill>
+                  <a:srgbClr val="586C7C"/>
+                </a:solidFill>
+                <a:latin typeface="Helvetica Neue"/>
+                <a:ea typeface="Helvetica Neue"/>
+                <a:cs typeface="Helvetica Neue"/>
+              </a:defRPr>
+            </a:lvl8pPr>
+            <a:lvl9pPr>
+              <a:defRPr sz="1800" b="0">
+                <a:solidFill>
+                  <a:srgbClr val="586C7C"/>
+                </a:solidFill>
+                <a:latin typeface="Helvetica Neue"/>
+                <a:ea typeface="Helvetica Neue"/>
+                <a:cs typeface="Helvetica Neue"/>
+              </a:defRPr>
+            </a:lvl9pPr>
+          </a:lstStyle>
+          <a:p xmlns:a="http://schemas.openxmlformats.org/drawingml/2006/main">
+            <a:pPr>
+              <a:defRPr sz="1800" b="0">
+                <a:solidFill>
+                  <a:srgbClr val="586C7C"/>
+                </a:solidFill>
+                <a:latin typeface="Helvetica Neue"/>
+                <a:ea typeface="Helvetica Neue"/>
+                <a:cs typeface="Helvetica Neue"/>
+              </a:defRPr>
+            </a:pPr>
+            <a:r>
+              <a:rPr sz="1800" b="0">
+                <a:solidFill>
+                  <a:srgbClr val="586C7C"/>
+                </a:solidFill>
+                <a:latin typeface="Helvetica Neue"/>
+                <a:ea typeface="Helvetica Neue"/>
+                <a:cs typeface="Helvetica Neue"/>
+              </a:rPr>
+              <a:t>Sports, matched pipeline seed 44. Actual validation NDCG@10.</a:t>
             </a:r>
           </a:p>
         </p:txBody>
@@ -20843,6 +21304,7 @@
               </a:defRPr>
             </a:defPPr>
             <a:lvl1pPr>
+              <a:buNone/>
               <a:defRPr sz="3075" b="1">
                 <a:solidFill>
                   <a:srgbClr val="17243C"/>
@@ -20853,6 +21315,7 @@
               </a:defRPr>
             </a:lvl1pPr>
             <a:lvl2pPr>
+              <a:buNone/>
               <a:defRPr sz="3075" b="1">
                 <a:solidFill>
                   <a:srgbClr val="17243C"/>
@@ -20863,6 +21326,7 @@
               </a:defRPr>
             </a:lvl2pPr>
             <a:lvl3pPr>
+              <a:buNone/>
               <a:defRPr sz="3075" b="1">
                 <a:solidFill>
                   <a:srgbClr val="17243C"/>
@@ -20873,6 +21337,7 @@
               </a:defRPr>
             </a:lvl3pPr>
             <a:lvl4pPr>
+              <a:buNone/>
               <a:defRPr sz="3075" b="1">
                 <a:solidFill>
                   <a:srgbClr val="17243C"/>
@@ -20883,6 +21348,7 @@
               </a:defRPr>
             </a:lvl4pPr>
             <a:lvl5pPr>
+              <a:buNone/>
               <a:defRPr sz="3075" b="1">
                 <a:solidFill>
                   <a:srgbClr val="17243C"/>
@@ -20893,6 +21359,7 @@
               </a:defRPr>
             </a:lvl5pPr>
             <a:lvl6pPr>
+              <a:buNone/>
               <a:defRPr sz="3075" b="1">
                 <a:solidFill>
                   <a:srgbClr val="17243C"/>
@@ -20903,6 +21370,7 @@
               </a:defRPr>
             </a:lvl6pPr>
             <a:lvl7pPr>
+              <a:buNone/>
               <a:defRPr sz="3075" b="1">
                 <a:solidFill>
                   <a:srgbClr val="17243C"/>
@@ -20913,6 +21381,7 @@
               </a:defRPr>
             </a:lvl7pPr>
             <a:lvl8pPr>
+              <a:buNone/>
               <a:defRPr sz="3075" b="1">
                 <a:solidFill>
                   <a:srgbClr val="17243C"/>
@@ -20923,6 +21392,7 @@
               </a:defRPr>
             </a:lvl8pPr>
             <a:lvl9pPr>
+              <a:buNone/>
               <a:defRPr sz="3075" b="1">
                 <a:solidFill>
                   <a:srgbClr val="17243C"/>
@@ -20935,6 +21405,7 @@
           </a:lstStyle>
           <a:p xmlns:a="http://schemas.openxmlformats.org/drawingml/2006/main">
             <a:pPr>
+              <a:buNone/>
               <a:defRPr sz="3075" b="1">
                 <a:solidFill>
                   <a:srgbClr val="17243C"/>
@@ -21001,6 +21472,7 @@
               </a:defRPr>
             </a:defPPr>
             <a:lvl1pPr algn="r">
+              <a:buNone/>
               <a:defRPr sz="1275" b="0">
                 <a:solidFill>
                   <a:srgbClr val="586C7C"/>
@@ -21011,6 +21483,7 @@
               </a:defRPr>
             </a:lvl1pPr>
             <a:lvl2pPr algn="r">
+              <a:buNone/>
               <a:defRPr sz="1275" b="0">
                 <a:solidFill>
                   <a:srgbClr val="586C7C"/>
@@ -21021,6 +21494,7 @@
               </a:defRPr>
             </a:lvl2pPr>
             <a:lvl3pPr algn="r">
+              <a:buNone/>
               <a:defRPr sz="1275" b="0">
                 <a:solidFill>
                   <a:srgbClr val="586C7C"/>
@@ -21031,6 +21505,7 @@
               </a:defRPr>
             </a:lvl3pPr>
             <a:lvl4pPr algn="r">
+              <a:buNone/>
               <a:defRPr sz="1275" b="0">
                 <a:solidFill>
                   <a:srgbClr val="586C7C"/>
@@ -21041,6 +21516,7 @@
               </a:defRPr>
             </a:lvl4pPr>
             <a:lvl5pPr algn="r">
+              <a:buNone/>
               <a:defRPr sz="1275" b="0">
                 <a:solidFill>
                   <a:srgbClr val="586C7C"/>
@@ -21051,6 +21527,7 @@
               </a:defRPr>
             </a:lvl5pPr>
             <a:lvl6pPr algn="r">
+              <a:buNone/>
               <a:defRPr sz="1275" b="0">
                 <a:solidFill>
                   <a:srgbClr val="586C7C"/>
@@ -21061,6 +21538,7 @@
               </a:defRPr>
             </a:lvl6pPr>
             <a:lvl7pPr algn="r">
+              <a:buNone/>
               <a:defRPr sz="1275" b="0">
                 <a:solidFill>
                   <a:srgbClr val="586C7C"/>
@@ -21071,6 +21549,7 @@
               </a:defRPr>
             </a:lvl7pPr>
             <a:lvl8pPr algn="r">
+              <a:buNone/>
               <a:defRPr sz="1275" b="0">
                 <a:solidFill>
                   <a:srgbClr val="586C7C"/>
@@ -21081,6 +21560,7 @@
               </a:defRPr>
             </a:lvl8pPr>
             <a:lvl9pPr algn="r">
+              <a:buNone/>
               <a:defRPr sz="1275" b="0">
                 <a:solidFill>
                   <a:srgbClr val="586C7C"/>
@@ -21093,6 +21573,7 @@
           </a:lstStyle>
           <a:p xmlns:a="http://schemas.openxmlformats.org/drawingml/2006/main">
             <a:pPr algn="r">
+              <a:buNone/>
               <a:defRPr sz="1275" b="0">
                 <a:solidFill>
                   <a:srgbClr val="586C7C"/>
@@ -21159,6 +21640,7 @@
               </a:defRPr>
             </a:defPPr>
             <a:lvl1pPr>
+              <a:buNone/>
               <a:defRPr sz="2325" b="1">
                 <a:solidFill>
                   <a:srgbClr val="17243C"/>
@@ -21169,6 +21651,7 @@
               </a:defRPr>
             </a:lvl1pPr>
             <a:lvl2pPr>
+              <a:buNone/>
               <a:defRPr sz="2325" b="1">
                 <a:solidFill>
                   <a:srgbClr val="17243C"/>
@@ -21179,6 +21662,7 @@
               </a:defRPr>
             </a:lvl2pPr>
             <a:lvl3pPr>
+              <a:buNone/>
               <a:defRPr sz="2325" b="1">
                 <a:solidFill>
                   <a:srgbClr val="17243C"/>
@@ -21189,6 +21673,7 @@
               </a:defRPr>
             </a:lvl3pPr>
             <a:lvl4pPr>
+              <a:buNone/>
               <a:defRPr sz="2325" b="1">
                 <a:solidFill>
                   <a:srgbClr val="17243C"/>
@@ -21199,6 +21684,7 @@
               </a:defRPr>
             </a:lvl4pPr>
             <a:lvl5pPr>
+              <a:buNone/>
               <a:defRPr sz="2325" b="1">
                 <a:solidFill>
                   <a:srgbClr val="17243C"/>
@@ -21209,6 +21695,7 @@
               </a:defRPr>
             </a:lvl5pPr>
             <a:lvl6pPr>
+              <a:buNone/>
               <a:defRPr sz="2325" b="1">
                 <a:solidFill>
                   <a:srgbClr val="17243C"/>
@@ -21219,6 +21706,7 @@
               </a:defRPr>
             </a:lvl6pPr>
             <a:lvl7pPr>
+              <a:buNone/>
               <a:defRPr sz="2325" b="1">
                 <a:solidFill>
                   <a:srgbClr val="17243C"/>
@@ -21229,6 +21717,7 @@
               </a:defRPr>
             </a:lvl7pPr>
             <a:lvl8pPr>
+              <a:buNone/>
               <a:defRPr sz="2325" b="1">
                 <a:solidFill>
                   <a:srgbClr val="17243C"/>
@@ -21239,6 +21728,7 @@
               </a:defRPr>
             </a:lvl8pPr>
             <a:lvl9pPr>
+              <a:buNone/>
               <a:defRPr sz="2325" b="1">
                 <a:solidFill>
                   <a:srgbClr val="17243C"/>
@@ -21251,6 +21741,7 @@
           </a:lstStyle>
           <a:p xmlns:a="http://schemas.openxmlformats.org/drawingml/2006/main">
             <a:pPr>
+              <a:buNone/>
               <a:defRPr sz="2325" b="1">
                 <a:solidFill>
                   <a:srgbClr val="17243C"/>
@@ -21317,6 +21808,7 @@
               </a:defRPr>
             </a:defPPr>
             <a:lvl1pPr>
+              <a:buNone/>
               <a:defRPr sz="2100" b="0">
                 <a:solidFill>
                   <a:srgbClr val="586C7C"/>
@@ -21327,6 +21819,7 @@
               </a:defRPr>
             </a:lvl1pPr>
             <a:lvl2pPr>
+              <a:buNone/>
               <a:defRPr sz="2100" b="0">
                 <a:solidFill>
                   <a:srgbClr val="586C7C"/>
@@ -21337,6 +21830,7 @@
               </a:defRPr>
             </a:lvl2pPr>
             <a:lvl3pPr>
+              <a:buNone/>
               <a:defRPr sz="2100" b="0">
                 <a:solidFill>
                   <a:srgbClr val="586C7C"/>
@@ -21347,6 +21841,7 @@
               </a:defRPr>
             </a:lvl3pPr>
             <a:lvl4pPr>
+              <a:buNone/>
               <a:defRPr sz="2100" b="0">
                 <a:solidFill>
                   <a:srgbClr val="586C7C"/>
@@ -21357,6 +21852,7 @@
               </a:defRPr>
             </a:lvl4pPr>
             <a:lvl5pPr>
+              <a:buNone/>
               <a:defRPr sz="2100" b="0">
                 <a:solidFill>
                   <a:srgbClr val="586C7C"/>
@@ -21367,6 +21863,7 @@
               </a:defRPr>
             </a:lvl5pPr>
             <a:lvl6pPr>
+              <a:buNone/>
               <a:defRPr sz="2100" b="0">
                 <a:solidFill>
                   <a:srgbClr val="586C7C"/>
@@ -21377,6 +21874,7 @@
               </a:defRPr>
             </a:lvl6pPr>
             <a:lvl7pPr>
+              <a:buNone/>
               <a:defRPr sz="2100" b="0">
                 <a:solidFill>
                   <a:srgbClr val="586C7C"/>
@@ -21387,6 +21885,7 @@
               </a:defRPr>
             </a:lvl7pPr>
             <a:lvl8pPr>
+              <a:buNone/>
               <a:defRPr sz="2100" b="0">
                 <a:solidFill>
                   <a:srgbClr val="586C7C"/>
@@ -21397,6 +21896,7 @@
               </a:defRPr>
             </a:lvl8pPr>
             <a:lvl9pPr>
+              <a:buNone/>
               <a:defRPr sz="2100" b="0">
                 <a:solidFill>
                   <a:srgbClr val="586C7C"/>
@@ -21409,6 +21909,7 @@
           </a:lstStyle>
           <a:p xmlns:a="http://schemas.openxmlformats.org/drawingml/2006/main">
             <a:pPr>
+              <a:buNone/>
               <a:defRPr sz="2100" b="0">
                 <a:solidFill>
                   <a:srgbClr val="586C7C"/>
@@ -21432,6 +21933,7 @@
           </a:p>
           <a:p xmlns:a="http://schemas.openxmlformats.org/drawingml/2006/main">
             <a:pPr>
+              <a:buNone/>
               <a:defRPr sz="2100" b="0">
                 <a:solidFill>
                   <a:srgbClr val="586C7C"/>
@@ -21455,6 +21957,7 @@
           </a:p>
           <a:p xmlns:a="http://schemas.openxmlformats.org/drawingml/2006/main">
             <a:pPr>
+              <a:buNone/>
               <a:defRPr sz="2100" b="0">
                 <a:solidFill>
                   <a:srgbClr val="586C7C"/>
@@ -21521,6 +22024,7 @@
               </a:defRPr>
             </a:defPPr>
             <a:lvl1pPr>
+              <a:buNone/>
               <a:defRPr sz="2325" b="1">
                 <a:solidFill>
                   <a:srgbClr val="17243C"/>
@@ -21531,6 +22035,7 @@
               </a:defRPr>
             </a:lvl1pPr>
             <a:lvl2pPr>
+              <a:buNone/>
               <a:defRPr sz="2325" b="1">
                 <a:solidFill>
                   <a:srgbClr val="17243C"/>
@@ -21541,6 +22046,7 @@
               </a:defRPr>
             </a:lvl2pPr>
             <a:lvl3pPr>
+              <a:buNone/>
               <a:defRPr sz="2325" b="1">
                 <a:solidFill>
                   <a:srgbClr val="17243C"/>
@@ -21551,6 +22057,7 @@
               </a:defRPr>
             </a:lvl3pPr>
             <a:lvl4pPr>
+              <a:buNone/>
               <a:defRPr sz="2325" b="1">
                 <a:solidFill>
                   <a:srgbClr val="17243C"/>
@@ -21561,6 +22068,7 @@
               </a:defRPr>
             </a:lvl4pPr>
             <a:lvl5pPr>
+              <a:buNone/>
               <a:defRPr sz="2325" b="1">
                 <a:solidFill>
                   <a:srgbClr val="17243C"/>
@@ -21571,6 +22079,7 @@
               </a:defRPr>
             </a:lvl5pPr>
             <a:lvl6pPr>
+              <a:buNone/>
               <a:defRPr sz="2325" b="1">
                 <a:solidFill>
                   <a:srgbClr val="17243C"/>
@@ -21581,6 +22090,7 @@
               </a:defRPr>
             </a:lvl6pPr>
             <a:lvl7pPr>
+              <a:buNone/>
               <a:defRPr sz="2325" b="1">
                 <a:solidFill>
                   <a:srgbClr val="17243C"/>
@@ -21591,6 +22101,7 @@
               </a:defRPr>
             </a:lvl7pPr>
             <a:lvl8pPr>
+              <a:buNone/>
               <a:defRPr sz="2325" b="1">
                 <a:solidFill>
                   <a:srgbClr val="17243C"/>
@@ -21601,6 +22112,7 @@
               </a:defRPr>
             </a:lvl8pPr>
             <a:lvl9pPr>
+              <a:buNone/>
               <a:defRPr sz="2325" b="1">
                 <a:solidFill>
                   <a:srgbClr val="17243C"/>
@@ -21613,6 +22125,7 @@
           </a:lstStyle>
           <a:p xmlns:a="http://schemas.openxmlformats.org/drawingml/2006/main">
             <a:pPr>
+              <a:buNone/>
               <a:defRPr sz="2325" b="1">
                 <a:solidFill>
                   <a:srgbClr val="17243C"/>
@@ -21631,7 +22144,7 @@
                 <a:ea typeface="Helvetica Neue"/>
                 <a:cs typeface="Helvetica Neue"/>
               </a:rPr>
-              <a:t>Evidence in the project</a:t>
+              <a:t>Report, code and offline evidence</a:t>
             </a:r>
           </a:p>
         </p:txBody>
@@ -21679,6 +22192,7 @@
               </a:defRPr>
             </a:defPPr>
             <a:lvl1pPr>
+              <a:buNone/>
               <a:defRPr sz="2100" b="0">
                 <a:solidFill>
                   <a:srgbClr val="586C7C"/>
@@ -21689,6 +22203,7 @@
               </a:defRPr>
             </a:lvl1pPr>
             <a:lvl2pPr>
+              <a:buNone/>
               <a:defRPr sz="2100" b="0">
                 <a:solidFill>
                   <a:srgbClr val="586C7C"/>
@@ -21699,6 +22214,7 @@
               </a:defRPr>
             </a:lvl2pPr>
             <a:lvl3pPr>
+              <a:buNone/>
               <a:defRPr sz="2100" b="0">
                 <a:solidFill>
                   <a:srgbClr val="586C7C"/>
@@ -21709,6 +22225,7 @@
               </a:defRPr>
             </a:lvl3pPr>
             <a:lvl4pPr>
+              <a:buNone/>
               <a:defRPr sz="2100" b="0">
                 <a:solidFill>
                   <a:srgbClr val="586C7C"/>
@@ -21719,6 +22236,7 @@
               </a:defRPr>
             </a:lvl4pPr>
             <a:lvl5pPr>
+              <a:buNone/>
               <a:defRPr sz="2100" b="0">
                 <a:solidFill>
                   <a:srgbClr val="586C7C"/>
@@ -21729,6 +22247,7 @@
               </a:defRPr>
             </a:lvl5pPr>
             <a:lvl6pPr>
+              <a:buNone/>
               <a:defRPr sz="2100" b="0">
                 <a:solidFill>
                   <a:srgbClr val="586C7C"/>
@@ -21739,6 +22258,7 @@
               </a:defRPr>
             </a:lvl6pPr>
             <a:lvl7pPr>
+              <a:buNone/>
               <a:defRPr sz="2100" b="0">
                 <a:solidFill>
                   <a:srgbClr val="586C7C"/>
@@ -21749,6 +22269,7 @@
               </a:defRPr>
             </a:lvl7pPr>
             <a:lvl8pPr>
+              <a:buNone/>
               <a:defRPr sz="2100" b="0">
                 <a:solidFill>
                   <a:srgbClr val="586C7C"/>
@@ -21759,6 +22280,7 @@
               </a:defRPr>
             </a:lvl8pPr>
             <a:lvl9pPr>
+              <a:buNone/>
               <a:defRPr sz="2100" b="0">
                 <a:solidFill>
                   <a:srgbClr val="586C7C"/>
@@ -21771,6 +22293,7 @@
           </a:lstStyle>
           <a:p xmlns:a="http://schemas.openxmlformats.org/drawingml/2006/main">
             <a:pPr>
+              <a:buNone/>
               <a:defRPr sz="2100" b="0">
                 <a:solidFill>
                   <a:srgbClr val="586C7C"/>
@@ -21789,11 +22312,12 @@
                 <a:ea typeface="Helvetica Neue"/>
                 <a:cs typeface="Helvetica Neue"/>
               </a:rPr>
-              <a:t>27-record results summary and raw aggregate results</a:t>
+              <a:t>English experiment report and audited 27-record summary</a:t>
             </a:r>
           </a:p>
           <a:p xmlns:a="http://schemas.openxmlformats.org/drawingml/2006/main">
             <a:pPr>
+              <a:buNone/>
               <a:defRPr sz="2100" b="0">
                 <a:solidFill>
                   <a:srgbClr val="586C7C"/>
@@ -21812,11 +22336,12 @@
                 <a:ea typeface="Helvetica Neue"/>
                 <a:cs typeface="Helvetica Neue"/>
               </a:rPr>
-              <a:t>Selected model exports, hashes and training records</a:t>
+              <a:t>Selected model exports, hashes and recorded validation results</a:t>
             </a:r>
           </a:p>
           <a:p xmlns:a="http://schemas.openxmlformats.org/drawingml/2006/main">
             <a:pPr>
+              <a:buNone/>
               <a:defRPr sz="2100" b="0">
                 <a:solidFill>
                   <a:srgbClr val="586C7C"/>
@@ -21835,7 +22360,7 @@
                 <a:ea typeface="Helvetica Neue"/>
                 <a:cs typeface="Helvetica Neue"/>
               </a:rPr>
-              <a:t>Actual interface captures and source-referenced speaker notes</a:t>
+              <a:t>Experiment gallery: seven interactive figures plus CSV / JSON</a:t>
             </a:r>
           </a:p>
         </p:txBody>
@@ -21883,6 +22408,7 @@
               </a:defRPr>
             </a:defPPr>
             <a:lvl1pPr>
+              <a:buNone/>
               <a:defRPr sz="1650" b="0">
                 <a:solidFill>
                   <a:srgbClr val="586C7C"/>
@@ -21893,6 +22419,7 @@
               </a:defRPr>
             </a:lvl1pPr>
             <a:lvl2pPr>
+              <a:buNone/>
               <a:defRPr sz="1650" b="0">
                 <a:solidFill>
                   <a:srgbClr val="586C7C"/>
@@ -21903,6 +22430,7 @@
               </a:defRPr>
             </a:lvl2pPr>
             <a:lvl3pPr>
+              <a:buNone/>
               <a:defRPr sz="1650" b="0">
                 <a:solidFill>
                   <a:srgbClr val="586C7C"/>
@@ -21913,6 +22441,7 @@
               </a:defRPr>
             </a:lvl3pPr>
             <a:lvl4pPr>
+              <a:buNone/>
               <a:defRPr sz="1650" b="0">
                 <a:solidFill>
                   <a:srgbClr val="586C7C"/>
@@ -21923,6 +22452,7 @@
               </a:defRPr>
             </a:lvl4pPr>
             <a:lvl5pPr>
+              <a:buNone/>
               <a:defRPr sz="1650" b="0">
                 <a:solidFill>
                   <a:srgbClr val="586C7C"/>
@@ -21933,6 +22463,7 @@
               </a:defRPr>
             </a:lvl5pPr>
             <a:lvl6pPr>
+              <a:buNone/>
               <a:defRPr sz="1650" b="0">
                 <a:solidFill>
                   <a:srgbClr val="586C7C"/>
@@ -21943,6 +22474,7 @@
               </a:defRPr>
             </a:lvl6pPr>
             <a:lvl7pPr>
+              <a:buNone/>
               <a:defRPr sz="1650" b="0">
                 <a:solidFill>
                   <a:srgbClr val="586C7C"/>
@@ -21953,6 +22485,7 @@
               </a:defRPr>
             </a:lvl7pPr>
             <a:lvl8pPr>
+              <a:buNone/>
               <a:defRPr sz="1650" b="0">
                 <a:solidFill>
                   <a:srgbClr val="586C7C"/>
@@ -21963,6 +22496,7 @@
               </a:defRPr>
             </a:lvl8pPr>
             <a:lvl9pPr>
+              <a:buNone/>
               <a:defRPr sz="1650" b="0">
                 <a:solidFill>
                   <a:srgbClr val="586C7C"/>
@@ -21975,6 +22509,7 @@
           </a:lstStyle>
           <a:p xmlns:a="http://schemas.openxmlformats.org/drawingml/2006/main">
             <a:pPr>
+              <a:buNone/>
               <a:defRPr sz="1650" b="0">
                 <a:solidFill>
                   <a:srgbClr val="586C7C"/>
@@ -21993,7 +22528,7 @@
                 <a:ea typeface="Helvetica Neue"/>
                 <a:cs typeface="Helvetica Neue"/>
               </a:rPr>
-              <a:t>The team must complete genuine contributions, AI disclosure and a human recording.</a:t>
+              <a:t>The export script creates the optional offline gallery. Runtime assets install separately.</a:t>
             </a:r>
           </a:p>
         </p:txBody>
@@ -23655,7 +24190,7 @@
                 <a:ea typeface="Helvetica Neue"/>
                 <a:cs typeface="Helvetica Neue"/>
               </a:rPr>
-              <a:t>These are three domains from one Amazon source. Course acceptance needs confirmation.</a:t>
+              <a:t>Three domains from one Amazon source limit evidence about cross-source generalization.</a:t>
             </a:r>
           </a:p>
         </p:txBody>
@@ -26675,6 +27210,7 @@
               </a:defRPr>
             </a:defPPr>
             <a:lvl1pPr>
+              <a:buNone/>
               <a:defRPr sz="3075" b="1">
                 <a:solidFill>
                   <a:srgbClr val="17243C"/>
@@ -26685,6 +27221,7 @@
               </a:defRPr>
             </a:lvl1pPr>
             <a:lvl2pPr>
+              <a:buNone/>
               <a:defRPr sz="3075" b="1">
                 <a:solidFill>
                   <a:srgbClr val="17243C"/>
@@ -26695,6 +27232,7 @@
               </a:defRPr>
             </a:lvl2pPr>
             <a:lvl3pPr>
+              <a:buNone/>
               <a:defRPr sz="3075" b="1">
                 <a:solidFill>
                   <a:srgbClr val="17243C"/>
@@ -26705,6 +27243,7 @@
               </a:defRPr>
             </a:lvl3pPr>
             <a:lvl4pPr>
+              <a:buNone/>
               <a:defRPr sz="3075" b="1">
                 <a:solidFill>
                   <a:srgbClr val="17243C"/>
@@ -26715,6 +27254,7 @@
               </a:defRPr>
             </a:lvl4pPr>
             <a:lvl5pPr>
+              <a:buNone/>
               <a:defRPr sz="3075" b="1">
                 <a:solidFill>
                   <a:srgbClr val="17243C"/>
@@ -26725,6 +27265,7 @@
               </a:defRPr>
             </a:lvl5pPr>
             <a:lvl6pPr>
+              <a:buNone/>
               <a:defRPr sz="3075" b="1">
                 <a:solidFill>
                   <a:srgbClr val="17243C"/>
@@ -26735,6 +27276,7 @@
               </a:defRPr>
             </a:lvl6pPr>
             <a:lvl7pPr>
+              <a:buNone/>
               <a:defRPr sz="3075" b="1">
                 <a:solidFill>
                   <a:srgbClr val="17243C"/>
@@ -26745,6 +27287,7 @@
               </a:defRPr>
             </a:lvl7pPr>
             <a:lvl8pPr>
+              <a:buNone/>
               <a:defRPr sz="3075" b="1">
                 <a:solidFill>
                   <a:srgbClr val="17243C"/>
@@ -26755,6 +27298,7 @@
               </a:defRPr>
             </a:lvl8pPr>
             <a:lvl9pPr>
+              <a:buNone/>
               <a:defRPr sz="3075" b="1">
                 <a:solidFill>
                   <a:srgbClr val="17243C"/>
@@ -26767,6 +27311,7 @@
           </a:lstStyle>
           <a:p xmlns:a="http://schemas.openxmlformats.org/drawingml/2006/main">
             <a:pPr>
+              <a:buNone/>
               <a:defRPr sz="3075" b="1">
                 <a:solidFill>
                   <a:srgbClr val="17243C"/>
@@ -26785,7 +27330,7 @@
                 <a:ea typeface="Helvetica Neue"/>
                 <a:cs typeface="Helvetica Neue"/>
               </a:rPr>
-              <a:t>Seed variation in the Research lab</a:t>
+              <a:t>Experiment gallery: every recorded seed</a:t>
             </a:r>
           </a:p>
         </p:txBody>
@@ -26833,6 +27378,7 @@
               </a:defRPr>
             </a:defPPr>
             <a:lvl1pPr>
+              <a:buNone/>
               <a:defRPr sz="1800" b="0">
                 <a:solidFill>
                   <a:srgbClr val="586C7C"/>
@@ -26843,6 +27389,7 @@
               </a:defRPr>
             </a:lvl1pPr>
             <a:lvl2pPr>
+              <a:buNone/>
               <a:defRPr sz="1800" b="0">
                 <a:solidFill>
                   <a:srgbClr val="586C7C"/>
@@ -26853,6 +27400,7 @@
               </a:defRPr>
             </a:lvl2pPr>
             <a:lvl3pPr>
+              <a:buNone/>
               <a:defRPr sz="1800" b="0">
                 <a:solidFill>
                   <a:srgbClr val="586C7C"/>
@@ -26863,6 +27411,7 @@
               </a:defRPr>
             </a:lvl3pPr>
             <a:lvl4pPr>
+              <a:buNone/>
               <a:defRPr sz="1800" b="0">
                 <a:solidFill>
                   <a:srgbClr val="586C7C"/>
@@ -26873,6 +27422,7 @@
               </a:defRPr>
             </a:lvl4pPr>
             <a:lvl5pPr>
+              <a:buNone/>
               <a:defRPr sz="1800" b="0">
                 <a:solidFill>
                   <a:srgbClr val="586C7C"/>
@@ -26883,6 +27433,7 @@
               </a:defRPr>
             </a:lvl5pPr>
             <a:lvl6pPr>
+              <a:buNone/>
               <a:defRPr sz="1800" b="0">
                 <a:solidFill>
                   <a:srgbClr val="586C7C"/>
@@ -26893,6 +27444,7 @@
               </a:defRPr>
             </a:lvl6pPr>
             <a:lvl7pPr>
+              <a:buNone/>
               <a:defRPr sz="1800" b="0">
                 <a:solidFill>
                   <a:srgbClr val="586C7C"/>
@@ -26903,6 +27455,7 @@
               </a:defRPr>
             </a:lvl7pPr>
             <a:lvl8pPr>
+              <a:buNone/>
               <a:defRPr sz="1800" b="0">
                 <a:solidFill>
                   <a:srgbClr val="586C7C"/>
@@ -26913,6 +27466,7 @@
               </a:defRPr>
             </a:lvl8pPr>
             <a:lvl9pPr>
+              <a:buNone/>
               <a:defRPr sz="1800" b="0">
                 <a:solidFill>
                   <a:srgbClr val="586C7C"/>
@@ -26925,6 +27479,7 @@
           </a:lstStyle>
           <a:p xmlns:a="http://schemas.openxmlformats.org/drawingml/2006/main">
             <a:pPr>
+              <a:buNone/>
               <a:defRPr sz="1800" b="0">
                 <a:solidFill>
                   <a:srgbClr val="586C7C"/>
@@ -26943,7 +27498,7 @@
                 <a:ea typeface="Helvetica Neue"/>
                 <a:cs typeface="Helvetica Neue"/>
               </a:rPr>
-              <a:t>Actual matched-seed changes remain visible alongside the aggregated result.</a:t>
+              <a:t>18 matched comparisons against Frozen, from the original 27 formal test records</a:t>
             </a:r>
           </a:p>
         </p:txBody>
@@ -26991,6 +27546,7 @@
               </a:defRPr>
             </a:defPPr>
             <a:lvl1pPr algn="r">
+              <a:buNone/>
               <a:defRPr sz="1275" b="0">
                 <a:solidFill>
                   <a:srgbClr val="586C7C"/>
@@ -27001,6 +27557,7 @@
               </a:defRPr>
             </a:lvl1pPr>
             <a:lvl2pPr algn="r">
+              <a:buNone/>
               <a:defRPr sz="1275" b="0">
                 <a:solidFill>
                   <a:srgbClr val="586C7C"/>
@@ -27011,6 +27568,7 @@
               </a:defRPr>
             </a:lvl2pPr>
             <a:lvl3pPr algn="r">
+              <a:buNone/>
               <a:defRPr sz="1275" b="0">
                 <a:solidFill>
                   <a:srgbClr val="586C7C"/>
@@ -27021,6 +27579,7 @@
               </a:defRPr>
             </a:lvl3pPr>
             <a:lvl4pPr algn="r">
+              <a:buNone/>
               <a:defRPr sz="1275" b="0">
                 <a:solidFill>
                   <a:srgbClr val="586C7C"/>
@@ -27031,6 +27590,7 @@
               </a:defRPr>
             </a:lvl4pPr>
             <a:lvl5pPr algn="r">
+              <a:buNone/>
               <a:defRPr sz="1275" b="0">
                 <a:solidFill>
                   <a:srgbClr val="586C7C"/>
@@ -27041,6 +27601,7 @@
               </a:defRPr>
             </a:lvl5pPr>
             <a:lvl6pPr algn="r">
+              <a:buNone/>
               <a:defRPr sz="1275" b="0">
                 <a:solidFill>
                   <a:srgbClr val="586C7C"/>
@@ -27051,6 +27612,7 @@
               </a:defRPr>
             </a:lvl6pPr>
             <a:lvl7pPr algn="r">
+              <a:buNone/>
               <a:defRPr sz="1275" b="0">
                 <a:solidFill>
                   <a:srgbClr val="586C7C"/>
@@ -27061,6 +27623,7 @@
               </a:defRPr>
             </a:lvl7pPr>
             <a:lvl8pPr algn="r">
+              <a:buNone/>
               <a:defRPr sz="1275" b="0">
                 <a:solidFill>
                   <a:srgbClr val="586C7C"/>
@@ -27071,6 +27634,7 @@
               </a:defRPr>
             </a:lvl8pPr>
             <a:lvl9pPr algn="r">
+              <a:buNone/>
               <a:defRPr sz="1275" b="0">
                 <a:solidFill>
                   <a:srgbClr val="586C7C"/>
@@ -27083,6 +27647,7 @@
           </a:lstStyle>
           <a:p xmlns:a="http://schemas.openxmlformats.org/drawingml/2006/main">
             <a:pPr algn="r">
+              <a:buNone/>
               <a:defRPr sz="1275" b="0">
                 <a:solidFill>
                   <a:srgbClr val="586C7C"/>
@@ -27111,7 +27676,7 @@
           <p:cNvPr id="4" name="">
             <a:extLst xmlns:a="http://schemas.openxmlformats.org/drawingml/2006/main">
               <a:ext uri="{FF2B5EF4-FFF2-40B4-BE49-F238E27FC236}">
-                <a16:creationId xmlns:a16="http://schemas.microsoft.com/office/drawing/2014/main" id="{2C6CCA8E-1B5E-47A4-B344-0F6F8FB71B05}"/>
+                <a16:creationId xmlns:a16="http://schemas.microsoft.com/office/drawing/2014/main" id="{CF63EF3F-14E0-405F-996B-2B43DE5E45C0}"/>
               </a:ext>
             </a:extLst>
           </p:cNvPr>
@@ -27121,14 +27686,14 @@
           <p:nvPr/>
         </p:nvPicPr>
         <p:blipFill>
-          <a:blip xmlns:r="http://schemas.openxmlformats.org/officeDocument/2006/relationships" xmlns:a="http://schemas.openxmlformats.org/drawingml/2006/main" r:embed="R5369d28273674be0"/>
-          <a:srcRect xmlns:a="http://schemas.openxmlformats.org/drawingml/2006/main" l="1500" t="22000" r="1500" b="18000"/>
+          <a:blip xmlns:r="http://schemas.openxmlformats.org/officeDocument/2006/relationships" xmlns:a="http://schemas.openxmlformats.org/drawingml/2006/main" r:embed="Ra7b4c9cee9d64b37"/>
+          <a:srcRect xmlns:a="http://schemas.openxmlformats.org/drawingml/2006/main" l="6250" t="20139" r="6250" b="833"/>
           <a:stretch xmlns:a="http://schemas.openxmlformats.org/drawingml/2006/main"/>
         </p:blipFill>
         <p:spPr>
           <a:xfrm xmlns:a="http://schemas.openxmlformats.org/drawingml/2006/main">
-            <a:off x="2258128" y="1485900"/>
-            <a:ext cx="7675744" cy="4457700"/>
+            <a:off x="1708499" y="1485900"/>
+            <a:ext cx="8775097" cy="4457700"/>
           </a:xfrm>
           <a:prstGeom xmlns:a="http://schemas.openxmlformats.org/drawingml/2006/main" prst="rect">
             <a:avLst/>
@@ -27151,8 +27716,8 @@
         </p:nvSpPr>
         <p:spPr>
           <a:xfrm xmlns:a="http://schemas.openxmlformats.org/drawingml/2006/main">
-            <a:off x="628650" y="6057900"/>
-            <a:ext cx="10839450" cy="304800"/>
+            <a:off x="628650" y="6000750"/>
+            <a:ext cx="10839450" cy="514350"/>
           </a:xfrm>
           <a:prstGeom xmlns:a="http://schemas.openxmlformats.org/drawingml/2006/main" prst="rect">
             <a:avLst/>
@@ -27178,6 +27743,7 @@
               </a:defRPr>
             </a:defPPr>
             <a:lvl1pPr>
+              <a:buNone/>
               <a:defRPr sz="1650" b="0">
                 <a:solidFill>
                   <a:srgbClr val="586C7C"/>
@@ -27188,6 +27754,7 @@
               </a:defRPr>
             </a:lvl1pPr>
             <a:lvl2pPr>
+              <a:buNone/>
               <a:defRPr sz="1650" b="0">
                 <a:solidFill>
                   <a:srgbClr val="586C7C"/>
@@ -27198,6 +27765,7 @@
               </a:defRPr>
             </a:lvl2pPr>
             <a:lvl3pPr>
+              <a:buNone/>
               <a:defRPr sz="1650" b="0">
                 <a:solidFill>
                   <a:srgbClr val="586C7C"/>
@@ -27208,6 +27776,7 @@
               </a:defRPr>
             </a:lvl3pPr>
             <a:lvl4pPr>
+              <a:buNone/>
               <a:defRPr sz="1650" b="0">
                 <a:solidFill>
                   <a:srgbClr val="586C7C"/>
@@ -27218,6 +27787,7 @@
               </a:defRPr>
             </a:lvl4pPr>
             <a:lvl5pPr>
+              <a:buNone/>
               <a:defRPr sz="1650" b="0">
                 <a:solidFill>
                   <a:srgbClr val="586C7C"/>
@@ -27228,6 +27798,7 @@
               </a:defRPr>
             </a:lvl5pPr>
             <a:lvl6pPr>
+              <a:buNone/>
               <a:defRPr sz="1650" b="0">
                 <a:solidFill>
                   <a:srgbClr val="586C7C"/>
@@ -27238,6 +27809,7 @@
               </a:defRPr>
             </a:lvl6pPr>
             <a:lvl7pPr>
+              <a:buNone/>
               <a:defRPr sz="1650" b="0">
                 <a:solidFill>
                   <a:srgbClr val="586C7C"/>
@@ -27248,6 +27820,7 @@
               </a:defRPr>
             </a:lvl7pPr>
             <a:lvl8pPr>
+              <a:buNone/>
               <a:defRPr sz="1650" b="0">
                 <a:solidFill>
                   <a:srgbClr val="586C7C"/>
@@ -27258,6 +27831,7 @@
               </a:defRPr>
             </a:lvl8pPr>
             <a:lvl9pPr>
+              <a:buNone/>
               <a:defRPr sz="1650" b="0">
                 <a:solidFill>
                   <a:srgbClr val="586C7C"/>
@@ -27270,6 +27844,7 @@
           </a:lstStyle>
           <a:p xmlns:a="http://schemas.openxmlformats.org/drawingml/2006/main">
             <a:pPr>
+              <a:buNone/>
               <a:defRPr sz="1650" b="0">
                 <a:solidFill>
                   <a:srgbClr val="586C7C"/>
@@ -27288,7 +27863,31 @@
                 <a:ea typeface="Helvetica Neue"/>
                 <a:cs typeface="Helvetica Neue"/>
               </a:rPr>
-              <a:t>Three seeds describe variation. They do not establish significance or a confidence interval.</a:t>
+              <a:t>Columns: seeds 42, 43 and 44. Cells: actual Δ NDCG@10.</a:t>
+            </a:r>
+          </a:p>
+          <a:p xmlns:a="http://schemas.openxmlformats.org/drawingml/2006/main">
+            <a:pPr>
+              <a:buNone/>
+              <a:defRPr sz="1650" b="0">
+                <a:solidFill>
+                  <a:srgbClr val="586C7C"/>
+                </a:solidFill>
+                <a:latin typeface="Helvetica Neue"/>
+                <a:ea typeface="Helvetica Neue"/>
+                <a:cs typeface="Helvetica Neue"/>
+              </a:defRPr>
+            </a:pPr>
+            <a:r>
+              <a:rPr sz="1650" b="0">
+                <a:solidFill>
+                  <a:srgbClr val="586C7C"/>
+                </a:solidFill>
+                <a:latin typeface="Helvetica Neue"/>
+                <a:ea typeface="Helvetica Neue"/>
+                <a:cs typeface="Helvetica Neue"/>
+              </a:rPr>
+              <a:t>Coral falls below Frozen. Teal exceeds Frozen. Three seeds do not establish significance.</a:t>
             </a:r>
           </a:p>
         </p:txBody>
@@ -27897,6 +28496,7 @@
               </a:defRPr>
             </a:defPPr>
             <a:lvl1pPr>
+              <a:buNone/>
               <a:defRPr sz="3075" b="1">
                 <a:solidFill>
                   <a:srgbClr val="17243C"/>
@@ -27907,6 +28507,7 @@
               </a:defRPr>
             </a:lvl1pPr>
             <a:lvl2pPr>
+              <a:buNone/>
               <a:defRPr sz="3075" b="1">
                 <a:solidFill>
                   <a:srgbClr val="17243C"/>
@@ -27917,6 +28518,7 @@
               </a:defRPr>
             </a:lvl2pPr>
             <a:lvl3pPr>
+              <a:buNone/>
               <a:defRPr sz="3075" b="1">
                 <a:solidFill>
                   <a:srgbClr val="17243C"/>
@@ -27927,6 +28529,7 @@
               </a:defRPr>
             </a:lvl3pPr>
             <a:lvl4pPr>
+              <a:buNone/>
               <a:defRPr sz="3075" b="1">
                 <a:solidFill>
                   <a:srgbClr val="17243C"/>
@@ -27937,6 +28540,7 @@
               </a:defRPr>
             </a:lvl4pPr>
             <a:lvl5pPr>
+              <a:buNone/>
               <a:defRPr sz="3075" b="1">
                 <a:solidFill>
                   <a:srgbClr val="17243C"/>
@@ -27947,6 +28551,7 @@
               </a:defRPr>
             </a:lvl5pPr>
             <a:lvl6pPr>
+              <a:buNone/>
               <a:defRPr sz="3075" b="1">
                 <a:solidFill>
                   <a:srgbClr val="17243C"/>
@@ -27957,6 +28562,7 @@
               </a:defRPr>
             </a:lvl6pPr>
             <a:lvl7pPr>
+              <a:buNone/>
               <a:defRPr sz="3075" b="1">
                 <a:solidFill>
                   <a:srgbClr val="17243C"/>
@@ -27967,6 +28573,7 @@
               </a:defRPr>
             </a:lvl7pPr>
             <a:lvl8pPr>
+              <a:buNone/>
               <a:defRPr sz="3075" b="1">
                 <a:solidFill>
                   <a:srgbClr val="17243C"/>
@@ -27977,6 +28584,7 @@
               </a:defRPr>
             </a:lvl8pPr>
             <a:lvl9pPr>
+              <a:buNone/>
               <a:defRPr sz="3075" b="1">
                 <a:solidFill>
                   <a:srgbClr val="17243C"/>
@@ -27989,6 +28597,7 @@
           </a:lstStyle>
           <a:p xmlns:a="http://schemas.openxmlformats.org/drawingml/2006/main">
             <a:pPr>
+              <a:buNone/>
               <a:defRPr sz="3075" b="1">
                 <a:solidFill>
                   <a:srgbClr val="17243C"/>
@@ -28007,7 +28616,7 @@
                 <a:ea typeface="Helvetica Neue"/>
                 <a:cs typeface="Helvetica Neue"/>
               </a:rPr>
-              <a:t>The same request across three trained models</a:t>
+              <a:t>Model arena: one product across three models</a:t>
             </a:r>
           </a:p>
         </p:txBody>
@@ -28055,6 +28664,7 @@
               </a:defRPr>
             </a:defPPr>
             <a:lvl1pPr>
+              <a:buNone/>
               <a:defRPr sz="1800" b="0">
                 <a:solidFill>
                   <a:srgbClr val="586C7C"/>
@@ -28065,6 +28675,7 @@
               </a:defRPr>
             </a:lvl1pPr>
             <a:lvl2pPr>
+              <a:buNone/>
               <a:defRPr sz="1800" b="0">
                 <a:solidFill>
                   <a:srgbClr val="586C7C"/>
@@ -28075,6 +28686,7 @@
               </a:defRPr>
             </a:lvl2pPr>
             <a:lvl3pPr>
+              <a:buNone/>
               <a:defRPr sz="1800" b="0">
                 <a:solidFill>
                   <a:srgbClr val="586C7C"/>
@@ -28085,6 +28697,7 @@
               </a:defRPr>
             </a:lvl3pPr>
             <a:lvl4pPr>
+              <a:buNone/>
               <a:defRPr sz="1800" b="0">
                 <a:solidFill>
                   <a:srgbClr val="586C7C"/>
@@ -28095,6 +28708,7 @@
               </a:defRPr>
             </a:lvl4pPr>
             <a:lvl5pPr>
+              <a:buNone/>
               <a:defRPr sz="1800" b="0">
                 <a:solidFill>
                   <a:srgbClr val="586C7C"/>
@@ -28105,6 +28719,7 @@
               </a:defRPr>
             </a:lvl5pPr>
             <a:lvl6pPr>
+              <a:buNone/>
               <a:defRPr sz="1800" b="0">
                 <a:solidFill>
                   <a:srgbClr val="586C7C"/>
@@ -28115,6 +28730,7 @@
               </a:defRPr>
             </a:lvl6pPr>
             <a:lvl7pPr>
+              <a:buNone/>
               <a:defRPr sz="1800" b="0">
                 <a:solidFill>
                   <a:srgbClr val="586C7C"/>
@@ -28125,6 +28741,7 @@
               </a:defRPr>
             </a:lvl7pPr>
             <a:lvl8pPr>
+              <a:buNone/>
               <a:defRPr sz="1800" b="0">
                 <a:solidFill>
                   <a:srgbClr val="586C7C"/>
@@ -28135,6 +28752,7 @@
               </a:defRPr>
             </a:lvl8pPr>
             <a:lvl9pPr>
+              <a:buNone/>
               <a:defRPr sz="1800" b="0">
                 <a:solidFill>
                   <a:srgbClr val="586C7C"/>
@@ -28147,6 +28765,7 @@
           </a:lstStyle>
           <a:p xmlns:a="http://schemas.openxmlformats.org/drawingml/2006/main">
             <a:pPr>
+              <a:buNone/>
               <a:defRPr sz="1800" b="0">
                 <a:solidFill>
                   <a:srgbClr val="586C7C"/>
@@ -28165,7 +28784,7 @@
                 <a:ea typeface="Helvetica Neue"/>
                 <a:cs typeface="Helvetica Neue"/>
               </a:rPr>
-              <a:t>Baby collection, with no positive feedback</a:t>
+              <a:t>“Find a stroller for everyday outings” in Baby, with no positive feedback</a:t>
             </a:r>
           </a:p>
         </p:txBody>
@@ -28213,6 +28832,7 @@
               </a:defRPr>
             </a:defPPr>
             <a:lvl1pPr algn="r">
+              <a:buNone/>
               <a:defRPr sz="1275" b="0">
                 <a:solidFill>
                   <a:srgbClr val="586C7C"/>
@@ -28223,6 +28843,7 @@
               </a:defRPr>
             </a:lvl1pPr>
             <a:lvl2pPr algn="r">
+              <a:buNone/>
               <a:defRPr sz="1275" b="0">
                 <a:solidFill>
                   <a:srgbClr val="586C7C"/>
@@ -28233,6 +28854,7 @@
               </a:defRPr>
             </a:lvl2pPr>
             <a:lvl3pPr algn="r">
+              <a:buNone/>
               <a:defRPr sz="1275" b="0">
                 <a:solidFill>
                   <a:srgbClr val="586C7C"/>
@@ -28243,6 +28865,7 @@
               </a:defRPr>
             </a:lvl3pPr>
             <a:lvl4pPr algn="r">
+              <a:buNone/>
               <a:defRPr sz="1275" b="0">
                 <a:solidFill>
                   <a:srgbClr val="586C7C"/>
@@ -28253,6 +28876,7 @@
               </a:defRPr>
             </a:lvl4pPr>
             <a:lvl5pPr algn="r">
+              <a:buNone/>
               <a:defRPr sz="1275" b="0">
                 <a:solidFill>
                   <a:srgbClr val="586C7C"/>
@@ -28263,6 +28887,7 @@
               </a:defRPr>
             </a:lvl5pPr>
             <a:lvl6pPr algn="r">
+              <a:buNone/>
               <a:defRPr sz="1275" b="0">
                 <a:solidFill>
                   <a:srgbClr val="586C7C"/>
@@ -28273,6 +28898,7 @@
               </a:defRPr>
             </a:lvl6pPr>
             <a:lvl7pPr algn="r">
+              <a:buNone/>
               <a:defRPr sz="1275" b="0">
                 <a:solidFill>
                   <a:srgbClr val="586C7C"/>
@@ -28283,6 +28909,7 @@
               </a:defRPr>
             </a:lvl7pPr>
             <a:lvl8pPr algn="r">
+              <a:buNone/>
               <a:defRPr sz="1275" b="0">
                 <a:solidFill>
                   <a:srgbClr val="586C7C"/>
@@ -28293,6 +28920,7 @@
               </a:defRPr>
             </a:lvl8pPr>
             <a:lvl9pPr algn="r">
+              <a:buNone/>
               <a:defRPr sz="1275" b="0">
                 <a:solidFill>
                   <a:srgbClr val="586C7C"/>
@@ -28305,6 +28933,7 @@
           </a:lstStyle>
           <a:p xmlns:a="http://schemas.openxmlformats.org/drawingml/2006/main">
             <a:pPr algn="r">
+              <a:buNone/>
               <a:defRPr sz="1275" b="0">
                 <a:solidFill>
                   <a:srgbClr val="586C7C"/>
@@ -28333,7 +28962,7 @@
           <p:cNvPr id="4" name="">
             <a:extLst xmlns:a="http://schemas.openxmlformats.org/drawingml/2006/main">
               <a:ext uri="{FF2B5EF4-FFF2-40B4-BE49-F238E27FC236}">
-                <a16:creationId xmlns:a16="http://schemas.microsoft.com/office/drawing/2014/main" id="{F8917DE5-60B7-4251-93E6-8F11E1D41DEE}"/>
+                <a16:creationId xmlns:a16="http://schemas.microsoft.com/office/drawing/2014/main" id="{B7BF1262-8997-40E7-A82F-177945EAFCF7}"/>
               </a:ext>
             </a:extLst>
           </p:cNvPr>
@@ -28343,14 +28972,14 @@
           <p:nvPr/>
         </p:nvPicPr>
         <p:blipFill>
-          <a:blip xmlns:r="http://schemas.openxmlformats.org/officeDocument/2006/relationships" xmlns:a="http://schemas.openxmlformats.org/drawingml/2006/main" r:embed="R7f1f15b0d5af44ec"/>
-          <a:srcRect xmlns:a="http://schemas.openxmlformats.org/drawingml/2006/main" l="25000" t="45000" r="4000" b="500"/>
+          <a:blip xmlns:r="http://schemas.openxmlformats.org/officeDocument/2006/relationships" xmlns:a="http://schemas.openxmlformats.org/drawingml/2006/main" r:embed="Rf2070ad7ae6644be"/>
+          <a:srcRect xmlns:a="http://schemas.openxmlformats.org/drawingml/2006/main" l="6250" t="8472" r="30625" b="833"/>
           <a:stretch xmlns:a="http://schemas.openxmlformats.org/drawingml/2006/main"/>
         </p:blipFill>
         <p:spPr>
           <a:xfrm xmlns:a="http://schemas.openxmlformats.org/drawingml/2006/main">
-            <a:off x="1914759" y="1485900"/>
-            <a:ext cx="8362482" cy="4457700"/>
+            <a:off x="609600" y="1485900"/>
+            <a:ext cx="5516689" cy="4457700"/>
           </a:xfrm>
           <a:prstGeom xmlns:a="http://schemas.openxmlformats.org/drawingml/2006/main" prst="rect">
             <a:avLst/>
@@ -28400,6 +29029,7 @@
               </a:defRPr>
             </a:defPPr>
             <a:lvl1pPr>
+              <a:buNone/>
               <a:defRPr sz="1650" b="0">
                 <a:solidFill>
                   <a:srgbClr val="586C7C"/>
@@ -28410,6 +29040,7 @@
               </a:defRPr>
             </a:lvl1pPr>
             <a:lvl2pPr>
+              <a:buNone/>
               <a:defRPr sz="1650" b="0">
                 <a:solidFill>
                   <a:srgbClr val="586C7C"/>
@@ -28420,6 +29051,7 @@
               </a:defRPr>
             </a:lvl2pPr>
             <a:lvl3pPr>
+              <a:buNone/>
               <a:defRPr sz="1650" b="0">
                 <a:solidFill>
                   <a:srgbClr val="586C7C"/>
@@ -28430,6 +29062,7 @@
               </a:defRPr>
             </a:lvl3pPr>
             <a:lvl4pPr>
+              <a:buNone/>
               <a:defRPr sz="1650" b="0">
                 <a:solidFill>
                   <a:srgbClr val="586C7C"/>
@@ -28440,6 +29073,7 @@
               </a:defRPr>
             </a:lvl4pPr>
             <a:lvl5pPr>
+              <a:buNone/>
               <a:defRPr sz="1650" b="0">
                 <a:solidFill>
                   <a:srgbClr val="586C7C"/>
@@ -28450,6 +29084,7 @@
               </a:defRPr>
             </a:lvl5pPr>
             <a:lvl6pPr>
+              <a:buNone/>
               <a:defRPr sz="1650" b="0">
                 <a:solidFill>
                   <a:srgbClr val="586C7C"/>
@@ -28460,6 +29095,7 @@
               </a:defRPr>
             </a:lvl6pPr>
             <a:lvl7pPr>
+              <a:buNone/>
               <a:defRPr sz="1650" b="0">
                 <a:solidFill>
                   <a:srgbClr val="586C7C"/>
@@ -28470,6 +29106,7 @@
               </a:defRPr>
             </a:lvl7pPr>
             <a:lvl8pPr>
+              <a:buNone/>
               <a:defRPr sz="1650" b="0">
                 <a:solidFill>
                   <a:srgbClr val="586C7C"/>
@@ -28480,6 +29117,7 @@
               </a:defRPr>
             </a:lvl8pPr>
             <a:lvl9pPr>
+              <a:buNone/>
               <a:defRPr sz="1650" b="0">
                 <a:solidFill>
                   <a:srgbClr val="586C7C"/>
@@ -28492,6 +29130,7 @@
           </a:lstStyle>
           <a:p xmlns:a="http://schemas.openxmlformats.org/drawingml/2006/main">
             <a:pPr>
+              <a:buNone/>
               <a:defRPr sz="1650" b="0">
                 <a:solidFill>
                   <a:srgbClr val="586C7C"/>
@@ -28510,11 +29149,12 @@
                 <a:ea typeface="Helvetica Neue"/>
                 <a:cs typeface="Helvetica Neue"/>
               </a:rPr>
-              <a:t>Baby has 7,037 products. Shown: each model’s first recommendation.</a:t>
+              <a:t>Each query matches its model’s candidate space. Missing Top-K positions stay unknown.</a:t>
             </a:r>
           </a:p>
           <a:p xmlns:a="http://schemas.openxmlformats.org/drawingml/2006/main">
             <a:pPr>
+              <a:buNone/>
               <a:defRPr sz="1650" b="0">
                 <a:solidFill>
                   <a:srgbClr val="586C7C"/>
@@ -28533,7 +29173,889 @@
                 <a:ea typeface="Helvetica Neue"/>
                 <a:cs typeface="Helvetica Neue"/>
               </a:rPr>
-              <a:t>Each query matches its candidate space. Rank differences do not measure quality.</a:t>
+              <a:t>These observed rank differences describe disagreement, without relevance labels.</a:t>
+            </a:r>
+          </a:p>
+        </p:txBody>
+      </p:sp>
+      <p:sp>
+        <p:nvSpPr>
+          <p:cNvPr id="7" name="">
+            <a:extLst xmlns:a="http://schemas.openxmlformats.org/drawingml/2006/main">
+              <a:ext uri="{FF2B5EF4-FFF2-40B4-BE49-F238E27FC236}">
+                <a16:creationId xmlns:a16="http://schemas.microsoft.com/office/drawing/2014/main" id="{87879BD7-F47C-4EF1-B401-92A9FB01ACD3}"/>
+              </a:ext>
+            </a:extLst>
+          </p:cNvPr>
+          <p:cNvSpPr>
+            <a:spLocks xmlns:a="http://schemas.openxmlformats.org/drawingml/2006/main" noGrp="1"/>
+          </p:cNvSpPr>
+          <p:nvPr/>
+        </p:nvSpPr>
+        <p:spPr>
+          <a:xfrm xmlns:a="http://schemas.openxmlformats.org/drawingml/2006/main">
+            <a:off x="6667500" y="1704975"/>
+            <a:ext cx="4724400" cy="733425"/>
+          </a:xfrm>
+          <a:prstGeom xmlns:a="http://schemas.openxmlformats.org/drawingml/2006/main" prst="rect">
+            <a:avLst/>
+          </a:prstGeom>
+          <a:noFill xmlns:a="http://schemas.openxmlformats.org/drawingml/2006/main"/>
+          <a:ln xmlns:a="http://schemas.openxmlformats.org/drawingml/2006/main" w="0">
+            <a:noFill/>
+          </a:ln>
+        </p:spPr>
+        <p:txBody>
+          <a:bodyPr xmlns:a="http://schemas.openxmlformats.org/drawingml/2006/main" wrap="square" lIns="0" tIns="0" rIns="0" bIns="0" anchor="t">
+            <a:noAutofit/>
+          </a:bodyPr>
+          <a:lstStyle xmlns:a="http://schemas.openxmlformats.org/drawingml/2006/main">
+            <a:defPPr>
+              <a:defRPr sz="1950" b="0">
+                <a:solidFill>
+                  <a:srgbClr val="586C7C"/>
+                </a:solidFill>
+                <a:latin typeface="Helvetica Neue"/>
+                <a:ea typeface="Helvetica Neue"/>
+                <a:cs typeface="Helvetica Neue"/>
+              </a:defRPr>
+            </a:defPPr>
+            <a:lvl1pPr>
+              <a:defRPr sz="1950" b="0">
+                <a:solidFill>
+                  <a:srgbClr val="586C7C"/>
+                </a:solidFill>
+                <a:latin typeface="Helvetica Neue"/>
+                <a:ea typeface="Helvetica Neue"/>
+                <a:cs typeface="Helvetica Neue"/>
+              </a:defRPr>
+            </a:lvl1pPr>
+            <a:lvl2pPr>
+              <a:defRPr sz="1950" b="0">
+                <a:solidFill>
+                  <a:srgbClr val="586C7C"/>
+                </a:solidFill>
+                <a:latin typeface="Helvetica Neue"/>
+                <a:ea typeface="Helvetica Neue"/>
+                <a:cs typeface="Helvetica Neue"/>
+              </a:defRPr>
+            </a:lvl2pPr>
+            <a:lvl3pPr>
+              <a:defRPr sz="1950" b="0">
+                <a:solidFill>
+                  <a:srgbClr val="586C7C"/>
+                </a:solidFill>
+                <a:latin typeface="Helvetica Neue"/>
+                <a:ea typeface="Helvetica Neue"/>
+                <a:cs typeface="Helvetica Neue"/>
+              </a:defRPr>
+            </a:lvl3pPr>
+            <a:lvl4pPr>
+              <a:defRPr sz="1950" b="0">
+                <a:solidFill>
+                  <a:srgbClr val="586C7C"/>
+                </a:solidFill>
+                <a:latin typeface="Helvetica Neue"/>
+                <a:ea typeface="Helvetica Neue"/>
+                <a:cs typeface="Helvetica Neue"/>
+              </a:defRPr>
+            </a:lvl4pPr>
+            <a:lvl5pPr>
+              <a:defRPr sz="1950" b="0">
+                <a:solidFill>
+                  <a:srgbClr val="586C7C"/>
+                </a:solidFill>
+                <a:latin typeface="Helvetica Neue"/>
+                <a:ea typeface="Helvetica Neue"/>
+                <a:cs typeface="Helvetica Neue"/>
+              </a:defRPr>
+            </a:lvl5pPr>
+            <a:lvl6pPr>
+              <a:defRPr sz="1950" b="0">
+                <a:solidFill>
+                  <a:srgbClr val="586C7C"/>
+                </a:solidFill>
+                <a:latin typeface="Helvetica Neue"/>
+                <a:ea typeface="Helvetica Neue"/>
+                <a:cs typeface="Helvetica Neue"/>
+              </a:defRPr>
+            </a:lvl6pPr>
+            <a:lvl7pPr>
+              <a:defRPr sz="1950" b="0">
+                <a:solidFill>
+                  <a:srgbClr val="586C7C"/>
+                </a:solidFill>
+                <a:latin typeface="Helvetica Neue"/>
+                <a:ea typeface="Helvetica Neue"/>
+                <a:cs typeface="Helvetica Neue"/>
+              </a:defRPr>
+            </a:lvl7pPr>
+            <a:lvl8pPr>
+              <a:defRPr sz="1950" b="0">
+                <a:solidFill>
+                  <a:srgbClr val="586C7C"/>
+                </a:solidFill>
+                <a:latin typeface="Helvetica Neue"/>
+                <a:ea typeface="Helvetica Neue"/>
+                <a:cs typeface="Helvetica Neue"/>
+              </a:defRPr>
+            </a:lvl8pPr>
+            <a:lvl9pPr>
+              <a:defRPr sz="1950" b="0">
+                <a:solidFill>
+                  <a:srgbClr val="586C7C"/>
+                </a:solidFill>
+                <a:latin typeface="Helvetica Neue"/>
+                <a:ea typeface="Helvetica Neue"/>
+                <a:cs typeface="Helvetica Neue"/>
+              </a:defRPr>
+            </a:lvl9pPr>
+          </a:lstStyle>
+          <a:p xmlns:a="http://schemas.openxmlformats.org/drawingml/2006/main">
+            <a:pPr>
+              <a:defRPr sz="1950" b="0">
+                <a:solidFill>
+                  <a:srgbClr val="586C7C"/>
+                </a:solidFill>
+                <a:latin typeface="Helvetica Neue"/>
+                <a:ea typeface="Helvetica Neue"/>
+                <a:cs typeface="Helvetica Neue"/>
+              </a:defRPr>
+            </a:pPr>
+            <a:r>
+              <a:rPr sz="1950" b="0">
+                <a:solidFill>
+                  <a:srgbClr val="586C7C"/>
+                </a:solidFill>
+                <a:latin typeface="Helvetica Neue"/>
+                <a:ea typeface="Helvetica Neue"/>
+                <a:cs typeface="Helvetica Neue"/>
+              </a:rPr>
+              <a:t>Dream On Me / Mia Moda Veloce</a:t>
+            </a:r>
+          </a:p>
+          <a:p xmlns:a="http://schemas.openxmlformats.org/drawingml/2006/main">
+            <a:pPr>
+              <a:defRPr sz="1950" b="0">
+                <a:solidFill>
+                  <a:srgbClr val="586C7C"/>
+                </a:solidFill>
+                <a:latin typeface="Helvetica Neue"/>
+                <a:ea typeface="Helvetica Neue"/>
+                <a:cs typeface="Helvetica Neue"/>
+              </a:defRPr>
+            </a:pPr>
+            <a:r>
+              <a:rPr sz="1950" b="0">
+                <a:solidFill>
+                  <a:srgbClr val="586C7C"/>
+                </a:solidFill>
+                <a:latin typeface="Helvetica Neue"/>
+                <a:ea typeface="Helvetica Neue"/>
+                <a:cs typeface="Helvetica Neue"/>
+              </a:rPr>
+              <a:t>ASIN B002UHJ0HK</a:t>
+            </a:r>
+          </a:p>
+        </p:txBody>
+      </p:sp>
+      <p:sp>
+        <p:nvSpPr>
+          <p:cNvPr id="8" name="">
+            <a:extLst xmlns:a="http://schemas.openxmlformats.org/drawingml/2006/main">
+              <a:ext uri="{FF2B5EF4-FFF2-40B4-BE49-F238E27FC236}">
+                <a16:creationId xmlns:a16="http://schemas.microsoft.com/office/drawing/2014/main" id="{B68F966E-E035-414F-A917-7A5A51A14353}"/>
+              </a:ext>
+            </a:extLst>
+          </p:cNvPr>
+          <p:cNvSpPr>
+            <a:spLocks xmlns:a="http://schemas.openxmlformats.org/drawingml/2006/main" noGrp="1"/>
+          </p:cNvSpPr>
+          <p:nvPr/>
+        </p:nvSpPr>
+        <p:spPr>
+          <a:xfrm xmlns:a="http://schemas.openxmlformats.org/drawingml/2006/main">
+            <a:off x="6667500" y="2686050"/>
+            <a:ext cx="4724400" cy="409575"/>
+          </a:xfrm>
+          <a:prstGeom xmlns:a="http://schemas.openxmlformats.org/drawingml/2006/main" prst="rect">
+            <a:avLst/>
+          </a:prstGeom>
+          <a:noFill xmlns:a="http://schemas.openxmlformats.org/drawingml/2006/main"/>
+          <a:ln xmlns:a="http://schemas.openxmlformats.org/drawingml/2006/main" w="0">
+            <a:noFill/>
+          </a:ln>
+        </p:spPr>
+        <p:txBody>
+          <a:bodyPr xmlns:a="http://schemas.openxmlformats.org/drawingml/2006/main" wrap="square" lIns="0" tIns="0" rIns="0" bIns="0" anchor="t">
+            <a:noAutofit/>
+          </a:bodyPr>
+          <a:lstStyle xmlns:a="http://schemas.openxmlformats.org/drawingml/2006/main">
+            <a:defPPr>
+              <a:defRPr sz="2400" b="1">
+                <a:solidFill>
+                  <a:srgbClr val="546982"/>
+                </a:solidFill>
+                <a:latin typeface="Helvetica Neue"/>
+                <a:ea typeface="Helvetica Neue"/>
+                <a:cs typeface="Helvetica Neue"/>
+              </a:defRPr>
+            </a:defPPr>
+            <a:lvl1pPr>
+              <a:defRPr sz="2400" b="1">
+                <a:solidFill>
+                  <a:srgbClr val="546982"/>
+                </a:solidFill>
+                <a:latin typeface="Helvetica Neue"/>
+                <a:ea typeface="Helvetica Neue"/>
+                <a:cs typeface="Helvetica Neue"/>
+              </a:defRPr>
+            </a:lvl1pPr>
+            <a:lvl2pPr>
+              <a:defRPr sz="2400" b="1">
+                <a:solidFill>
+                  <a:srgbClr val="546982"/>
+                </a:solidFill>
+                <a:latin typeface="Helvetica Neue"/>
+                <a:ea typeface="Helvetica Neue"/>
+                <a:cs typeface="Helvetica Neue"/>
+              </a:defRPr>
+            </a:lvl2pPr>
+            <a:lvl3pPr>
+              <a:defRPr sz="2400" b="1">
+                <a:solidFill>
+                  <a:srgbClr val="546982"/>
+                </a:solidFill>
+                <a:latin typeface="Helvetica Neue"/>
+                <a:ea typeface="Helvetica Neue"/>
+                <a:cs typeface="Helvetica Neue"/>
+              </a:defRPr>
+            </a:lvl3pPr>
+            <a:lvl4pPr>
+              <a:defRPr sz="2400" b="1">
+                <a:solidFill>
+                  <a:srgbClr val="546982"/>
+                </a:solidFill>
+                <a:latin typeface="Helvetica Neue"/>
+                <a:ea typeface="Helvetica Neue"/>
+                <a:cs typeface="Helvetica Neue"/>
+              </a:defRPr>
+            </a:lvl4pPr>
+            <a:lvl5pPr>
+              <a:defRPr sz="2400" b="1">
+                <a:solidFill>
+                  <a:srgbClr val="546982"/>
+                </a:solidFill>
+                <a:latin typeface="Helvetica Neue"/>
+                <a:ea typeface="Helvetica Neue"/>
+                <a:cs typeface="Helvetica Neue"/>
+              </a:defRPr>
+            </a:lvl5pPr>
+            <a:lvl6pPr>
+              <a:defRPr sz="2400" b="1">
+                <a:solidFill>
+                  <a:srgbClr val="546982"/>
+                </a:solidFill>
+                <a:latin typeface="Helvetica Neue"/>
+                <a:ea typeface="Helvetica Neue"/>
+                <a:cs typeface="Helvetica Neue"/>
+              </a:defRPr>
+            </a:lvl6pPr>
+            <a:lvl7pPr>
+              <a:defRPr sz="2400" b="1">
+                <a:solidFill>
+                  <a:srgbClr val="546982"/>
+                </a:solidFill>
+                <a:latin typeface="Helvetica Neue"/>
+                <a:ea typeface="Helvetica Neue"/>
+                <a:cs typeface="Helvetica Neue"/>
+              </a:defRPr>
+            </a:lvl7pPr>
+            <a:lvl8pPr>
+              <a:defRPr sz="2400" b="1">
+                <a:solidFill>
+                  <a:srgbClr val="546982"/>
+                </a:solidFill>
+                <a:latin typeface="Helvetica Neue"/>
+                <a:ea typeface="Helvetica Neue"/>
+                <a:cs typeface="Helvetica Neue"/>
+              </a:defRPr>
+            </a:lvl8pPr>
+            <a:lvl9pPr>
+              <a:defRPr sz="2400" b="1">
+                <a:solidFill>
+                  <a:srgbClr val="546982"/>
+                </a:solidFill>
+                <a:latin typeface="Helvetica Neue"/>
+                <a:ea typeface="Helvetica Neue"/>
+                <a:cs typeface="Helvetica Neue"/>
+              </a:defRPr>
+            </a:lvl9pPr>
+          </a:lstStyle>
+          <a:p xmlns:a="http://schemas.openxmlformats.org/drawingml/2006/main">
+            <a:pPr>
+              <a:defRPr sz="2400" b="1">
+                <a:solidFill>
+                  <a:srgbClr val="546982"/>
+                </a:solidFill>
+                <a:latin typeface="Helvetica Neue"/>
+                <a:ea typeface="Helvetica Neue"/>
+                <a:cs typeface="Helvetica Neue"/>
+              </a:defRPr>
+            </a:pPr>
+            <a:r>
+              <a:rPr sz="2400" b="1">
+                <a:solidFill>
+                  <a:srgbClr val="546982"/>
+                </a:solidFill>
+                <a:latin typeface="Helvetica Neue"/>
+                <a:ea typeface="Helvetica Neue"/>
+                <a:cs typeface="Helvetica Neue"/>
+              </a:rPr>
+              <a:t>Frozen #5</a:t>
+            </a:r>
+          </a:p>
+        </p:txBody>
+      </p:sp>
+      <p:sp>
+        <p:nvSpPr>
+          <p:cNvPr id="9" name="">
+            <a:extLst xmlns:a="http://schemas.openxmlformats.org/drawingml/2006/main">
+              <a:ext uri="{FF2B5EF4-FFF2-40B4-BE49-F238E27FC236}">
+                <a16:creationId xmlns:a16="http://schemas.microsoft.com/office/drawing/2014/main" id="{36A5894D-7699-4274-9E7A-7E8D92E63301}"/>
+              </a:ext>
+            </a:extLst>
+          </p:cNvPr>
+          <p:cNvSpPr>
+            <a:spLocks xmlns:a="http://schemas.openxmlformats.org/drawingml/2006/main" noGrp="1"/>
+          </p:cNvSpPr>
+          <p:nvPr/>
+        </p:nvSpPr>
+        <p:spPr>
+          <a:xfrm xmlns:a="http://schemas.openxmlformats.org/drawingml/2006/main">
+            <a:off x="6667500" y="3162300"/>
+            <a:ext cx="4724400" cy="409575"/>
+          </a:xfrm>
+          <a:prstGeom xmlns:a="http://schemas.openxmlformats.org/drawingml/2006/main" prst="rect">
+            <a:avLst/>
+          </a:prstGeom>
+          <a:noFill xmlns:a="http://schemas.openxmlformats.org/drawingml/2006/main"/>
+          <a:ln xmlns:a="http://schemas.openxmlformats.org/drawingml/2006/main" w="0">
+            <a:noFill/>
+          </a:ln>
+        </p:spPr>
+        <p:txBody>
+          <a:bodyPr xmlns:a="http://schemas.openxmlformats.org/drawingml/2006/main" wrap="square" lIns="0" tIns="0" rIns="0" bIns="0" anchor="t">
+            <a:noAutofit/>
+          </a:bodyPr>
+          <a:lstStyle xmlns:a="http://schemas.openxmlformats.org/drawingml/2006/main">
+            <a:defPPr>
+              <a:defRPr sz="2400" b="1">
+                <a:solidFill>
+                  <a:srgbClr val="347CDB"/>
+                </a:solidFill>
+                <a:latin typeface="Helvetica Neue"/>
+                <a:ea typeface="Helvetica Neue"/>
+                <a:cs typeface="Helvetica Neue"/>
+              </a:defRPr>
+            </a:defPPr>
+            <a:lvl1pPr>
+              <a:defRPr sz="2400" b="1">
+                <a:solidFill>
+                  <a:srgbClr val="347CDB"/>
+                </a:solidFill>
+                <a:latin typeface="Helvetica Neue"/>
+                <a:ea typeface="Helvetica Neue"/>
+                <a:cs typeface="Helvetica Neue"/>
+              </a:defRPr>
+            </a:lvl1pPr>
+            <a:lvl2pPr>
+              <a:defRPr sz="2400" b="1">
+                <a:solidFill>
+                  <a:srgbClr val="347CDB"/>
+                </a:solidFill>
+                <a:latin typeface="Helvetica Neue"/>
+                <a:ea typeface="Helvetica Neue"/>
+                <a:cs typeface="Helvetica Neue"/>
+              </a:defRPr>
+            </a:lvl2pPr>
+            <a:lvl3pPr>
+              <a:defRPr sz="2400" b="1">
+                <a:solidFill>
+                  <a:srgbClr val="347CDB"/>
+                </a:solidFill>
+                <a:latin typeface="Helvetica Neue"/>
+                <a:ea typeface="Helvetica Neue"/>
+                <a:cs typeface="Helvetica Neue"/>
+              </a:defRPr>
+            </a:lvl3pPr>
+            <a:lvl4pPr>
+              <a:defRPr sz="2400" b="1">
+                <a:solidFill>
+                  <a:srgbClr val="347CDB"/>
+                </a:solidFill>
+                <a:latin typeface="Helvetica Neue"/>
+                <a:ea typeface="Helvetica Neue"/>
+                <a:cs typeface="Helvetica Neue"/>
+              </a:defRPr>
+            </a:lvl4pPr>
+            <a:lvl5pPr>
+              <a:defRPr sz="2400" b="1">
+                <a:solidFill>
+                  <a:srgbClr val="347CDB"/>
+                </a:solidFill>
+                <a:latin typeface="Helvetica Neue"/>
+                <a:ea typeface="Helvetica Neue"/>
+                <a:cs typeface="Helvetica Neue"/>
+              </a:defRPr>
+            </a:lvl5pPr>
+            <a:lvl6pPr>
+              <a:defRPr sz="2400" b="1">
+                <a:solidFill>
+                  <a:srgbClr val="347CDB"/>
+                </a:solidFill>
+                <a:latin typeface="Helvetica Neue"/>
+                <a:ea typeface="Helvetica Neue"/>
+                <a:cs typeface="Helvetica Neue"/>
+              </a:defRPr>
+            </a:lvl6pPr>
+            <a:lvl7pPr>
+              <a:defRPr sz="2400" b="1">
+                <a:solidFill>
+                  <a:srgbClr val="347CDB"/>
+                </a:solidFill>
+                <a:latin typeface="Helvetica Neue"/>
+                <a:ea typeface="Helvetica Neue"/>
+                <a:cs typeface="Helvetica Neue"/>
+              </a:defRPr>
+            </a:lvl7pPr>
+            <a:lvl8pPr>
+              <a:defRPr sz="2400" b="1">
+                <a:solidFill>
+                  <a:srgbClr val="347CDB"/>
+                </a:solidFill>
+                <a:latin typeface="Helvetica Neue"/>
+                <a:ea typeface="Helvetica Neue"/>
+                <a:cs typeface="Helvetica Neue"/>
+              </a:defRPr>
+            </a:lvl8pPr>
+            <a:lvl9pPr>
+              <a:defRPr sz="2400" b="1">
+                <a:solidFill>
+                  <a:srgbClr val="347CDB"/>
+                </a:solidFill>
+                <a:latin typeface="Helvetica Neue"/>
+                <a:ea typeface="Helvetica Neue"/>
+                <a:cs typeface="Helvetica Neue"/>
+              </a:defRPr>
+            </a:lvl9pPr>
+          </a:lstStyle>
+          <a:p xmlns:a="http://schemas.openxmlformats.org/drawingml/2006/main">
+            <a:pPr>
+              <a:defRPr sz="2400" b="1">
+                <a:solidFill>
+                  <a:srgbClr val="347CDB"/>
+                </a:solidFill>
+                <a:latin typeface="Helvetica Neue"/>
+                <a:ea typeface="Helvetica Neue"/>
+                <a:cs typeface="Helvetica Neue"/>
+              </a:defRPr>
+            </a:pPr>
+            <a:r>
+              <a:rPr sz="2400" b="1">
+                <a:solidFill>
+                  <a:srgbClr val="347CDB"/>
+                </a:solidFill>
+                <a:latin typeface="Helvetica Neue"/>
+                <a:ea typeface="Helvetica Neue"/>
+                <a:cs typeface="Helvetica Neue"/>
+              </a:rPr>
+              <a:t>Semantic #1</a:t>
+            </a:r>
+          </a:p>
+        </p:txBody>
+      </p:sp>
+      <p:sp>
+        <p:nvSpPr>
+          <p:cNvPr id="10" name="">
+            <a:extLst xmlns:a="http://schemas.openxmlformats.org/drawingml/2006/main">
+              <a:ext uri="{FF2B5EF4-FFF2-40B4-BE49-F238E27FC236}">
+                <a16:creationId xmlns:a16="http://schemas.microsoft.com/office/drawing/2014/main" id="{B52A09F1-D017-4C36-99E8-E3E943CF2F55}"/>
+              </a:ext>
+            </a:extLst>
+          </p:cNvPr>
+          <p:cNvSpPr>
+            <a:spLocks xmlns:a="http://schemas.openxmlformats.org/drawingml/2006/main" noGrp="1"/>
+          </p:cNvSpPr>
+          <p:nvPr/>
+        </p:nvSpPr>
+        <p:spPr>
+          <a:xfrm xmlns:a="http://schemas.openxmlformats.org/drawingml/2006/main">
+            <a:off x="6667500" y="3638550"/>
+            <a:ext cx="4724400" cy="409575"/>
+          </a:xfrm>
+          <a:prstGeom xmlns:a="http://schemas.openxmlformats.org/drawingml/2006/main" prst="rect">
+            <a:avLst/>
+          </a:prstGeom>
+          <a:noFill xmlns:a="http://schemas.openxmlformats.org/drawingml/2006/main"/>
+          <a:ln xmlns:a="http://schemas.openxmlformats.org/drawingml/2006/main" w="0">
+            <a:noFill/>
+          </a:ln>
+        </p:spPr>
+        <p:txBody>
+          <a:bodyPr xmlns:a="http://schemas.openxmlformats.org/drawingml/2006/main" wrap="square" lIns="0" tIns="0" rIns="0" bIns="0" anchor="t">
+            <a:noAutofit/>
+          </a:bodyPr>
+          <a:lstStyle xmlns:a="http://schemas.openxmlformats.org/drawingml/2006/main">
+            <a:defPPr>
+              <a:defRPr sz="2400" b="1">
+                <a:solidFill>
+                  <a:srgbClr val="1A967B"/>
+                </a:solidFill>
+                <a:latin typeface="Helvetica Neue"/>
+                <a:ea typeface="Helvetica Neue"/>
+                <a:cs typeface="Helvetica Neue"/>
+              </a:defRPr>
+            </a:defPPr>
+            <a:lvl1pPr>
+              <a:defRPr sz="2400" b="1">
+                <a:solidFill>
+                  <a:srgbClr val="1A967B"/>
+                </a:solidFill>
+                <a:latin typeface="Helvetica Neue"/>
+                <a:ea typeface="Helvetica Neue"/>
+                <a:cs typeface="Helvetica Neue"/>
+              </a:defRPr>
+            </a:lvl1pPr>
+            <a:lvl2pPr>
+              <a:defRPr sz="2400" b="1">
+                <a:solidFill>
+                  <a:srgbClr val="1A967B"/>
+                </a:solidFill>
+                <a:latin typeface="Helvetica Neue"/>
+                <a:ea typeface="Helvetica Neue"/>
+                <a:cs typeface="Helvetica Neue"/>
+              </a:defRPr>
+            </a:lvl2pPr>
+            <a:lvl3pPr>
+              <a:defRPr sz="2400" b="1">
+                <a:solidFill>
+                  <a:srgbClr val="1A967B"/>
+                </a:solidFill>
+                <a:latin typeface="Helvetica Neue"/>
+                <a:ea typeface="Helvetica Neue"/>
+                <a:cs typeface="Helvetica Neue"/>
+              </a:defRPr>
+            </a:lvl3pPr>
+            <a:lvl4pPr>
+              <a:defRPr sz="2400" b="1">
+                <a:solidFill>
+                  <a:srgbClr val="1A967B"/>
+                </a:solidFill>
+                <a:latin typeface="Helvetica Neue"/>
+                <a:ea typeface="Helvetica Neue"/>
+                <a:cs typeface="Helvetica Neue"/>
+              </a:defRPr>
+            </a:lvl4pPr>
+            <a:lvl5pPr>
+              <a:defRPr sz="2400" b="1">
+                <a:solidFill>
+                  <a:srgbClr val="1A967B"/>
+                </a:solidFill>
+                <a:latin typeface="Helvetica Neue"/>
+                <a:ea typeface="Helvetica Neue"/>
+                <a:cs typeface="Helvetica Neue"/>
+              </a:defRPr>
+            </a:lvl5pPr>
+            <a:lvl6pPr>
+              <a:defRPr sz="2400" b="1">
+                <a:solidFill>
+                  <a:srgbClr val="1A967B"/>
+                </a:solidFill>
+                <a:latin typeface="Helvetica Neue"/>
+                <a:ea typeface="Helvetica Neue"/>
+                <a:cs typeface="Helvetica Neue"/>
+              </a:defRPr>
+            </a:lvl6pPr>
+            <a:lvl7pPr>
+              <a:defRPr sz="2400" b="1">
+                <a:solidFill>
+                  <a:srgbClr val="1A967B"/>
+                </a:solidFill>
+                <a:latin typeface="Helvetica Neue"/>
+                <a:ea typeface="Helvetica Neue"/>
+                <a:cs typeface="Helvetica Neue"/>
+              </a:defRPr>
+            </a:lvl7pPr>
+            <a:lvl8pPr>
+              <a:defRPr sz="2400" b="1">
+                <a:solidFill>
+                  <a:srgbClr val="1A967B"/>
+                </a:solidFill>
+                <a:latin typeface="Helvetica Neue"/>
+                <a:ea typeface="Helvetica Neue"/>
+                <a:cs typeface="Helvetica Neue"/>
+              </a:defRPr>
+            </a:lvl8pPr>
+            <a:lvl9pPr>
+              <a:defRPr sz="2400" b="1">
+                <a:solidFill>
+                  <a:srgbClr val="1A967B"/>
+                </a:solidFill>
+                <a:latin typeface="Helvetica Neue"/>
+                <a:ea typeface="Helvetica Neue"/>
+                <a:cs typeface="Helvetica Neue"/>
+              </a:defRPr>
+            </a:lvl9pPr>
+          </a:lstStyle>
+          <a:p xmlns:a="http://schemas.openxmlformats.org/drawingml/2006/main">
+            <a:pPr>
+              <a:defRPr sz="2400" b="1">
+                <a:solidFill>
+                  <a:srgbClr val="1A967B"/>
+                </a:solidFill>
+                <a:latin typeface="Helvetica Neue"/>
+                <a:ea typeface="Helvetica Neue"/>
+                <a:cs typeface="Helvetica Neue"/>
+              </a:defRPr>
+            </a:pPr>
+            <a:r>
+              <a:rPr sz="2400" b="1">
+                <a:solidFill>
+                  <a:srgbClr val="1A967B"/>
+                </a:solidFill>
+                <a:latin typeface="Helvetica Neue"/>
+                <a:ea typeface="Helvetica Neue"/>
+                <a:cs typeface="Helvetica Neue"/>
+              </a:rPr>
+              <a:t>Preference #6</a:t>
+            </a:r>
+          </a:p>
+        </p:txBody>
+      </p:sp>
+      <p:sp>
+        <p:nvSpPr>
+          <p:cNvPr id="11" name="">
+            <a:extLst xmlns:a="http://schemas.openxmlformats.org/drawingml/2006/main">
+              <a:ext uri="{FF2B5EF4-FFF2-40B4-BE49-F238E27FC236}">
+                <a16:creationId xmlns:a16="http://schemas.microsoft.com/office/drawing/2014/main" id="{EB92D1E5-FCE5-4A94-8AD3-B118B86B6454}"/>
+              </a:ext>
+            </a:extLst>
+          </p:cNvPr>
+          <p:cNvSpPr>
+            <a:spLocks xmlns:a="http://schemas.openxmlformats.org/drawingml/2006/main" noGrp="1"/>
+          </p:cNvSpPr>
+          <p:nvPr/>
+        </p:nvSpPr>
+        <p:spPr>
+          <a:xfrm xmlns:a="http://schemas.openxmlformats.org/drawingml/2006/main">
+            <a:off x="6667500" y="4410075"/>
+            <a:ext cx="4724400" cy="1333500"/>
+          </a:xfrm>
+          <a:prstGeom xmlns:a="http://schemas.openxmlformats.org/drawingml/2006/main" prst="rect">
+            <a:avLst/>
+          </a:prstGeom>
+          <a:noFill xmlns:a="http://schemas.openxmlformats.org/drawingml/2006/main"/>
+          <a:ln xmlns:a="http://schemas.openxmlformats.org/drawingml/2006/main" w="0">
+            <a:noFill/>
+          </a:ln>
+        </p:spPr>
+        <p:txBody>
+          <a:bodyPr xmlns:a="http://schemas.openxmlformats.org/drawingml/2006/main" wrap="square" lIns="0" tIns="0" rIns="0" bIns="0" anchor="t">
+            <a:noAutofit/>
+          </a:bodyPr>
+          <a:lstStyle xmlns:a="http://schemas.openxmlformats.org/drawingml/2006/main">
+            <a:defPPr>
+              <a:defRPr sz="2025" b="0">
+                <a:solidFill>
+                  <a:srgbClr val="586C7C"/>
+                </a:solidFill>
+                <a:latin typeface="Helvetica Neue"/>
+                <a:ea typeface="Helvetica Neue"/>
+                <a:cs typeface="Helvetica Neue"/>
+              </a:defRPr>
+            </a:defPPr>
+            <a:lvl1pPr>
+              <a:defRPr sz="2025" b="0">
+                <a:solidFill>
+                  <a:srgbClr val="586C7C"/>
+                </a:solidFill>
+                <a:latin typeface="Helvetica Neue"/>
+                <a:ea typeface="Helvetica Neue"/>
+                <a:cs typeface="Helvetica Neue"/>
+              </a:defRPr>
+            </a:lvl1pPr>
+            <a:lvl2pPr>
+              <a:defRPr sz="2025" b="0">
+                <a:solidFill>
+                  <a:srgbClr val="586C7C"/>
+                </a:solidFill>
+                <a:latin typeface="Helvetica Neue"/>
+                <a:ea typeface="Helvetica Neue"/>
+                <a:cs typeface="Helvetica Neue"/>
+              </a:defRPr>
+            </a:lvl2pPr>
+            <a:lvl3pPr>
+              <a:defRPr sz="2025" b="0">
+                <a:solidFill>
+                  <a:srgbClr val="586C7C"/>
+                </a:solidFill>
+                <a:latin typeface="Helvetica Neue"/>
+                <a:ea typeface="Helvetica Neue"/>
+                <a:cs typeface="Helvetica Neue"/>
+              </a:defRPr>
+            </a:lvl3pPr>
+            <a:lvl4pPr>
+              <a:defRPr sz="2025" b="0">
+                <a:solidFill>
+                  <a:srgbClr val="586C7C"/>
+                </a:solidFill>
+                <a:latin typeface="Helvetica Neue"/>
+                <a:ea typeface="Helvetica Neue"/>
+                <a:cs typeface="Helvetica Neue"/>
+              </a:defRPr>
+            </a:lvl4pPr>
+            <a:lvl5pPr>
+              <a:defRPr sz="2025" b="0">
+                <a:solidFill>
+                  <a:srgbClr val="586C7C"/>
+                </a:solidFill>
+                <a:latin typeface="Helvetica Neue"/>
+                <a:ea typeface="Helvetica Neue"/>
+                <a:cs typeface="Helvetica Neue"/>
+              </a:defRPr>
+            </a:lvl5pPr>
+            <a:lvl6pPr>
+              <a:defRPr sz="2025" b="0">
+                <a:solidFill>
+                  <a:srgbClr val="586C7C"/>
+                </a:solidFill>
+                <a:latin typeface="Helvetica Neue"/>
+                <a:ea typeface="Helvetica Neue"/>
+                <a:cs typeface="Helvetica Neue"/>
+              </a:defRPr>
+            </a:lvl6pPr>
+            <a:lvl7pPr>
+              <a:defRPr sz="2025" b="0">
+                <a:solidFill>
+                  <a:srgbClr val="586C7C"/>
+                </a:solidFill>
+                <a:latin typeface="Helvetica Neue"/>
+                <a:ea typeface="Helvetica Neue"/>
+                <a:cs typeface="Helvetica Neue"/>
+              </a:defRPr>
+            </a:lvl7pPr>
+            <a:lvl8pPr>
+              <a:defRPr sz="2025" b="0">
+                <a:solidFill>
+                  <a:srgbClr val="586C7C"/>
+                </a:solidFill>
+                <a:latin typeface="Helvetica Neue"/>
+                <a:ea typeface="Helvetica Neue"/>
+                <a:cs typeface="Helvetica Neue"/>
+              </a:defRPr>
+            </a:lvl8pPr>
+            <a:lvl9pPr>
+              <a:defRPr sz="2025" b="0">
+                <a:solidFill>
+                  <a:srgbClr val="586C7C"/>
+                </a:solidFill>
+                <a:latin typeface="Helvetica Neue"/>
+                <a:ea typeface="Helvetica Neue"/>
+                <a:cs typeface="Helvetica Neue"/>
+              </a:defRPr>
+            </a:lvl9pPr>
+          </a:lstStyle>
+          <a:p xmlns:a="http://schemas.openxmlformats.org/drawingml/2006/main">
+            <a:pPr>
+              <a:defRPr sz="2025" b="0">
+                <a:solidFill>
+                  <a:srgbClr val="586C7C"/>
+                </a:solidFill>
+                <a:latin typeface="Helvetica Neue"/>
+                <a:ea typeface="Helvetica Neue"/>
+                <a:cs typeface="Helvetica Neue"/>
+              </a:defRPr>
+            </a:pPr>
+            <a:r>
+              <a:rPr sz="2025" b="0">
+                <a:solidFill>
+                  <a:srgbClr val="586C7C"/>
+                </a:solidFill>
+                <a:latin typeface="Helvetica Neue"/>
+                <a:ea typeface="Helvetica Neue"/>
+                <a:cs typeface="Helvetica Neue"/>
+              </a:rPr>
+              <a:t>Observed Top 12 per model</a:t>
+            </a:r>
+          </a:p>
+          <a:p xmlns:a="http://schemas.openxmlformats.org/drawingml/2006/main">
+            <a:pPr>
+              <a:defRPr sz="2025" b="0">
+                <a:solidFill>
+                  <a:srgbClr val="586C7C"/>
+                </a:solidFill>
+                <a:latin typeface="Helvetica Neue"/>
+                <a:ea typeface="Helvetica Neue"/>
+                <a:cs typeface="Helvetica Neue"/>
+              </a:defRPr>
+            </a:pPr>
+            <a:r>
+              <a:rPr sz="2025" b="0">
+                <a:solidFill>
+                  <a:srgbClr val="586C7C"/>
+                </a:solidFill>
+                <a:latin typeface="Helvetica Neue"/>
+                <a:ea typeface="Helvetica Neue"/>
+                <a:cs typeface="Helvetica Neue"/>
+              </a:rPr>
+              <a:t>24 unique products</a:t>
+            </a:r>
+          </a:p>
+          <a:p xmlns:a="http://schemas.openxmlformats.org/drawingml/2006/main">
+            <a:pPr>
+              <a:defRPr sz="2025" b="0">
+                <a:solidFill>
+                  <a:srgbClr val="586C7C"/>
+                </a:solidFill>
+                <a:latin typeface="Helvetica Neue"/>
+                <a:ea typeface="Helvetica Neue"/>
+                <a:cs typeface="Helvetica Neue"/>
+              </a:defRPr>
+            </a:pPr>
+            <a:r>
+              <a:rPr sz="2025" b="0">
+                <a:solidFill>
+                  <a:srgbClr val="586C7C"/>
+                </a:solidFill>
+                <a:latin typeface="Helvetica Neue"/>
+                <a:ea typeface="Helvetica Neue"/>
+                <a:cs typeface="Helvetica Neue"/>
+              </a:rPr>
+              <a:t>2 in all three lists</a:t>
+            </a:r>
+          </a:p>
+          <a:p xmlns:a="http://schemas.openxmlformats.org/drawingml/2006/main">
+            <a:pPr>
+              <a:defRPr sz="2025" b="0">
+                <a:solidFill>
+                  <a:srgbClr val="586C7C"/>
+                </a:solidFill>
+                <a:latin typeface="Helvetica Neue"/>
+                <a:ea typeface="Helvetica Neue"/>
+                <a:cs typeface="Helvetica Neue"/>
+              </a:defRPr>
+            </a:pPr>
+            <a:r>
+              <a:rPr sz="2025" b="0">
+                <a:solidFill>
+                  <a:srgbClr val="586C7C"/>
+                </a:solidFill>
+                <a:latin typeface="Helvetica Neue"/>
+                <a:ea typeface="Helvetica Neue"/>
+                <a:cs typeface="Helvetica Neue"/>
+              </a:rPr>
+              <a:t>14 in exactly one list</a:t>
             </a:r>
           </a:p>
         </p:txBody>

</xml_diff>